<commit_message>
feat(presentation): Transform presentation deck to clean academic white background theme
</commit_message>
<xml_diff>
--- a/MelodyLoop_Presentation_Professional.pptx
+++ b/MelodyLoop_Presentation_Professional.pptx
@@ -5379,7 +5379,7 @@
             <a:avLst/>
           </a:prstGeom>
           <a:solidFill>
-            <a:srgbClr val="0B1020"/>
+            <a:srgbClr val="FFFFFF"/>
           </a:solidFill>
           <a:ln>
             <a:noFill/>
@@ -5422,7 +5422,7 @@
             <a:avLst/>
           </a:prstGeom>
           <a:solidFill>
-            <a:srgbClr val="26D9F1"/>
+            <a:srgbClr val="0284C7"/>
           </a:solidFill>
           <a:ln>
             <a:noFill/>
@@ -5475,7 +5475,7 @@
             <a:pPr>
               <a:defRPr sz="5000" b="1">
                 <a:solidFill>
-                  <a:srgbClr val="FFFFFF"/>
+                  <a:srgbClr val="0F172A"/>
                 </a:solidFill>
                 <a:latin typeface="Segoe UI"/>
               </a:defRPr>
@@ -5491,7 +5491,7 @@
               </a:spcBef>
               <a:defRPr sz="2600" b="1">
                 <a:solidFill>
-                  <a:srgbClr val="26D9F1"/>
+                  <a:srgbClr val="0284C7"/>
                 </a:solidFill>
                 <a:latin typeface="Segoe UI"/>
               </a:defRPr>
@@ -5507,7 +5507,7 @@
               </a:spcBef>
               <a:defRPr sz="1500">
                 <a:solidFill>
-                  <a:srgbClr val="E2E8F0"/>
+                  <a:srgbClr val="475569"/>
                 </a:solidFill>
                 <a:latin typeface="Segoe UI"/>
               </a:defRPr>
@@ -5533,11 +5533,11 @@
             <a:avLst/>
           </a:prstGeom>
           <a:solidFill>
-            <a:srgbClr val="151D36"/>
+            <a:srgbClr val="F8FAFC"/>
           </a:solidFill>
           <a:ln w="15240">
             <a:solidFill>
-              <a:srgbClr val="2A3B6A"/>
+              <a:srgbClr val="CBD5E1"/>
             </a:solidFill>
           </a:ln>
         </p:spPr>
@@ -5588,7 +5588,7 @@
             <a:pPr>
               <a:defRPr sz="2400" b="1">
                 <a:solidFill>
-                  <a:srgbClr val="26D9F1"/>
+                  <a:srgbClr val="0284C7"/>
                 </a:solidFill>
                 <a:latin typeface="Segoe UI"/>
               </a:defRPr>
@@ -5604,7 +5604,7 @@
               </a:spcBef>
               <a:defRPr sz="1200">
                 <a:solidFill>
-                  <a:srgbClr val="E2E8F0"/>
+                  <a:srgbClr val="475569"/>
                 </a:solidFill>
                 <a:latin typeface="Segoe UI"/>
               </a:defRPr>
@@ -5630,11 +5630,11 @@
             <a:avLst/>
           </a:prstGeom>
           <a:solidFill>
-            <a:srgbClr val="151D36"/>
+            <a:srgbClr val="F8FAFC"/>
           </a:solidFill>
           <a:ln w="15240">
             <a:solidFill>
-              <a:srgbClr val="2A3B6A"/>
+              <a:srgbClr val="CBD5E1"/>
             </a:solidFill>
           </a:ln>
         </p:spPr>
@@ -5685,7 +5685,7 @@
             <a:pPr>
               <a:defRPr sz="2400" b="1">
                 <a:solidFill>
-                  <a:srgbClr val="FFC857"/>
+                  <a:srgbClr val="D97706"/>
                 </a:solidFill>
                 <a:latin typeface="Segoe UI"/>
               </a:defRPr>
@@ -5701,7 +5701,7 @@
               </a:spcBef>
               <a:defRPr sz="1200">
                 <a:solidFill>
-                  <a:srgbClr val="E2E8F0"/>
+                  <a:srgbClr val="475569"/>
                 </a:solidFill>
                 <a:latin typeface="Segoe UI"/>
               </a:defRPr>
@@ -5727,11 +5727,11 @@
             <a:avLst/>
           </a:prstGeom>
           <a:solidFill>
-            <a:srgbClr val="151D36"/>
+            <a:srgbClr val="F8FAFC"/>
           </a:solidFill>
           <a:ln w="15240">
             <a:solidFill>
-              <a:srgbClr val="2A3B6A"/>
+              <a:srgbClr val="CBD5E1"/>
             </a:solidFill>
           </a:ln>
         </p:spPr>
@@ -5782,7 +5782,7 @@
             <a:pPr>
               <a:defRPr sz="2400" b="1">
                 <a:solidFill>
-                  <a:srgbClr val="FFFFFF"/>
+                  <a:srgbClr val="1E40AF"/>
                 </a:solidFill>
                 <a:latin typeface="Segoe UI"/>
               </a:defRPr>
@@ -5798,7 +5798,7 @@
               </a:spcBef>
               <a:defRPr sz="1200">
                 <a:solidFill>
-                  <a:srgbClr val="E2E8F0"/>
+                  <a:srgbClr val="475569"/>
                 </a:solidFill>
                 <a:latin typeface="Segoe UI"/>
               </a:defRPr>
@@ -5824,11 +5824,11 @@
             <a:avLst/>
           </a:prstGeom>
           <a:solidFill>
-            <a:srgbClr val="151D36"/>
+            <a:srgbClr val="F8FAFC"/>
           </a:solidFill>
           <a:ln w="15240">
             <a:solidFill>
-              <a:srgbClr val="2A3B6A"/>
+              <a:srgbClr val="CBD5E1"/>
             </a:solidFill>
           </a:ln>
         </p:spPr>
@@ -5879,7 +5879,7 @@
             <a:pPr>
               <a:defRPr sz="2400" b="1">
                 <a:solidFill>
-                  <a:srgbClr val="22C55E"/>
+                  <a:srgbClr val="16A34A"/>
                 </a:solidFill>
                 <a:latin typeface="Segoe UI"/>
               </a:defRPr>
@@ -5895,7 +5895,7 @@
               </a:spcBef>
               <a:defRPr sz="1200">
                 <a:solidFill>
-                  <a:srgbClr val="E2E8F0"/>
+                  <a:srgbClr val="475569"/>
                 </a:solidFill>
                 <a:latin typeface="Segoe UI"/>
               </a:defRPr>
@@ -5929,9 +5929,9 @@
           <a:lstStyle/>
           <a:p>
             <a:pPr>
-              <a:defRPr sz="1250">
-                <a:solidFill>
-                  <a:srgbClr val="FFFFFF"/>
+              <a:defRPr sz="1250" b="1">
+                <a:solidFill>
+                  <a:srgbClr val="0F172A"/>
                 </a:solidFill>
                 <a:latin typeface="Segoe UI"/>
               </a:defRPr>
@@ -5947,7 +5947,7 @@
               </a:spcBef>
               <a:defRPr sz="1150">
                 <a:solidFill>
-                  <a:srgbClr val="E2E8F0"/>
+                  <a:srgbClr val="475569"/>
                 </a:solidFill>
                 <a:latin typeface="Segoe UI"/>
               </a:defRPr>
@@ -5991,7 +5991,7 @@
             <a:avLst/>
           </a:prstGeom>
           <a:solidFill>
-            <a:srgbClr val="0B1020"/>
+            <a:srgbClr val="FFFFFF"/>
           </a:solidFill>
           <a:ln>
             <a:noFill/>
@@ -6034,7 +6034,7 @@
             <a:avLst/>
           </a:prstGeom>
           <a:solidFill>
-            <a:srgbClr val="26D9F1"/>
+            <a:srgbClr val="0284C7"/>
           </a:solidFill>
           <a:ln>
             <a:noFill/>
@@ -6087,7 +6087,7 @@
             <a:pPr>
               <a:defRPr sz="2600" b="1">
                 <a:solidFill>
-                  <a:srgbClr val="FFFFFF"/>
+                  <a:srgbClr val="0F172A"/>
                 </a:solidFill>
                 <a:latin typeface="Segoe UI"/>
               </a:defRPr>
@@ -6123,7 +6123,7 @@
             <a:pPr>
               <a:defRPr sz="950">
                 <a:solidFill>
-                  <a:srgbClr val="E2E8F0"/>
+                  <a:srgbClr val="64748B"/>
                 </a:solidFill>
                 <a:latin typeface="Segoe UI"/>
               </a:defRPr>
@@ -6149,11 +6149,11 @@
             <a:avLst/>
           </a:prstGeom>
           <a:solidFill>
-            <a:srgbClr val="151D36"/>
+            <a:srgbClr val="F8FAFC"/>
           </a:solidFill>
           <a:ln w="15240">
             <a:solidFill>
-              <a:srgbClr val="2A3B6A"/>
+              <a:srgbClr val="CBD5E1"/>
             </a:solidFill>
           </a:ln>
         </p:spPr>
@@ -6204,7 +6204,7 @@
             <a:pPr>
               <a:defRPr sz="1500" b="1">
                 <a:solidFill>
-                  <a:srgbClr val="E2E8F0"/>
+                  <a:srgbClr val="475569"/>
                 </a:solidFill>
               </a:defRPr>
             </a:pPr>
@@ -6219,7 +6219,7 @@
               </a:spcBef>
               <a:defRPr sz="1300" b="1">
                 <a:solidFill>
-                  <a:srgbClr val="FFFFFF"/>
+                  <a:srgbClr val="0F172A"/>
                 </a:solidFill>
               </a:defRPr>
             </a:pPr>
@@ -6234,7 +6234,7 @@
               </a:spcBef>
               <a:defRPr sz="1250">
                 <a:solidFill>
-                  <a:srgbClr val="E2E8F0"/>
+                  <a:srgbClr val="1E293B"/>
                 </a:solidFill>
               </a:defRPr>
             </a:pPr>
@@ -6271,11 +6271,11 @@
             <a:avLst/>
           </a:prstGeom>
           <a:solidFill>
-            <a:srgbClr val="151D36"/>
+            <a:srgbClr val="F8FAFC"/>
           </a:solidFill>
           <a:ln w="15240">
             <a:solidFill>
-              <a:srgbClr val="2A3B6A"/>
+              <a:srgbClr val="CBD5E1"/>
             </a:solidFill>
           </a:ln>
         </p:spPr>
@@ -6326,7 +6326,7 @@
             <a:pPr>
               <a:defRPr sz="1500" b="1">
                 <a:solidFill>
-                  <a:srgbClr val="FF6B6B"/>
+                  <a:srgbClr val="DC2626"/>
                 </a:solidFill>
               </a:defRPr>
             </a:pPr>
@@ -6341,7 +6341,7 @@
               </a:spcBef>
               <a:defRPr sz="1300" b="1">
                 <a:solidFill>
-                  <a:srgbClr val="FFFFFF"/>
+                  <a:srgbClr val="0F172A"/>
                 </a:solidFill>
               </a:defRPr>
             </a:pPr>
@@ -6356,7 +6356,7 @@
               </a:spcBef>
               <a:defRPr sz="1250">
                 <a:solidFill>
-                  <a:srgbClr val="E2E8F0"/>
+                  <a:srgbClr val="1E293B"/>
                 </a:solidFill>
               </a:defRPr>
             </a:pPr>
@@ -6393,11 +6393,11 @@
             <a:avLst/>
           </a:prstGeom>
           <a:solidFill>
-            <a:srgbClr val="151D36"/>
+            <a:srgbClr val="F8FAFC"/>
           </a:solidFill>
           <a:ln w="15240">
             <a:solidFill>
-              <a:srgbClr val="26D9F1"/>
+              <a:srgbClr val="0284C7"/>
             </a:solidFill>
           </a:ln>
         </p:spPr>
@@ -6448,7 +6448,7 @@
             <a:pPr>
               <a:defRPr sz="1500" b="1">
                 <a:solidFill>
-                  <a:srgbClr val="26D9F1"/>
+                  <a:srgbClr val="0284C7"/>
                 </a:solidFill>
               </a:defRPr>
             </a:pPr>
@@ -6463,7 +6463,7 @@
               </a:spcBef>
               <a:defRPr sz="1300" b="1">
                 <a:solidFill>
-                  <a:srgbClr val="FFFFFF"/>
+                  <a:srgbClr val="0F172A"/>
                 </a:solidFill>
               </a:defRPr>
             </a:pPr>
@@ -6478,7 +6478,7 @@
               </a:spcBef>
               <a:defRPr sz="1250">
                 <a:solidFill>
-                  <a:srgbClr val="E2E8F0"/>
+                  <a:srgbClr val="1E293B"/>
                 </a:solidFill>
               </a:defRPr>
             </a:pPr>
@@ -6533,7 +6533,7 @@
             <a:avLst/>
           </a:prstGeom>
           <a:solidFill>
-            <a:srgbClr val="0B1020"/>
+            <a:srgbClr val="FFFFFF"/>
           </a:solidFill>
           <a:ln>
             <a:noFill/>
@@ -6576,7 +6576,7 @@
             <a:avLst/>
           </a:prstGeom>
           <a:solidFill>
-            <a:srgbClr val="26D9F1"/>
+            <a:srgbClr val="0284C7"/>
           </a:solidFill>
           <a:ln>
             <a:noFill/>
@@ -6629,7 +6629,7 @@
             <a:pPr>
               <a:defRPr sz="2600" b="1">
                 <a:solidFill>
-                  <a:srgbClr val="FFFFFF"/>
+                  <a:srgbClr val="0F172A"/>
                 </a:solidFill>
                 <a:latin typeface="Segoe UI"/>
               </a:defRPr>
@@ -6665,7 +6665,7 @@
             <a:pPr>
               <a:defRPr sz="950">
                 <a:solidFill>
-                  <a:srgbClr val="E2E8F0"/>
+                  <a:srgbClr val="64748B"/>
                 </a:solidFill>
                 <a:latin typeface="Segoe UI"/>
               </a:defRPr>
@@ -6715,11 +6715,11 @@
             <a:avLst/>
           </a:prstGeom>
           <a:solidFill>
-            <a:srgbClr val="151D36"/>
+            <a:srgbClr val="F8FAFC"/>
           </a:solidFill>
           <a:ln w="15240">
             <a:solidFill>
-              <a:srgbClr val="2A3B6A"/>
+              <a:srgbClr val="CBD5E1"/>
             </a:solidFill>
           </a:ln>
         </p:spPr>
@@ -6770,7 +6770,7 @@
             <a:pPr>
               <a:defRPr sz="1400" b="1">
                 <a:solidFill>
-                  <a:srgbClr val="FF6B6B"/>
+                  <a:srgbClr val="DC2626"/>
                 </a:solidFill>
               </a:defRPr>
             </a:pPr>
@@ -6785,7 +6785,7 @@
               </a:spcBef>
               <a:defRPr sz="1150">
                 <a:solidFill>
-                  <a:srgbClr val="E2E8F0"/>
+                  <a:srgbClr val="1E293B"/>
                 </a:solidFill>
               </a:defRPr>
             </a:pPr>
@@ -6814,11 +6814,11 @@
             <a:avLst/>
           </a:prstGeom>
           <a:solidFill>
-            <a:srgbClr val="151D36"/>
+            <a:srgbClr val="F8FAFC"/>
           </a:solidFill>
           <a:ln w="15240">
             <a:solidFill>
-              <a:srgbClr val="2A3B6A"/>
+              <a:srgbClr val="CBD5E1"/>
             </a:solidFill>
           </a:ln>
         </p:spPr>
@@ -6869,7 +6869,7 @@
             <a:pPr>
               <a:defRPr sz="1400" b="1">
                 <a:solidFill>
-                  <a:srgbClr val="26D9F1"/>
+                  <a:srgbClr val="0284C7"/>
                 </a:solidFill>
               </a:defRPr>
             </a:pPr>
@@ -6884,7 +6884,7 @@
               </a:spcBef>
               <a:defRPr sz="1150">
                 <a:solidFill>
-                  <a:srgbClr val="E2E8F0"/>
+                  <a:srgbClr val="1E293B"/>
                 </a:solidFill>
               </a:defRPr>
             </a:pPr>
@@ -6913,11 +6913,11 @@
             <a:avLst/>
           </a:prstGeom>
           <a:solidFill>
-            <a:srgbClr val="151D36"/>
+            <a:srgbClr val="F8FAFC"/>
           </a:solidFill>
           <a:ln w="15240">
             <a:solidFill>
-              <a:srgbClr val="2A3B6A"/>
+              <a:srgbClr val="CBD5E1"/>
             </a:solidFill>
           </a:ln>
         </p:spPr>
@@ -6968,7 +6968,7 @@
             <a:pPr>
               <a:defRPr sz="1400" b="1">
                 <a:solidFill>
-                  <a:srgbClr val="22C55E"/>
+                  <a:srgbClr val="16A34A"/>
                 </a:solidFill>
               </a:defRPr>
             </a:pPr>
@@ -6983,7 +6983,7 @@
               </a:spcBef>
               <a:defRPr sz="1150">
                 <a:solidFill>
-                  <a:srgbClr val="E2E8F0"/>
+                  <a:srgbClr val="1E293B"/>
                 </a:solidFill>
               </a:defRPr>
             </a:pPr>
@@ -7012,11 +7012,11 @@
             <a:avLst/>
           </a:prstGeom>
           <a:solidFill>
-            <a:srgbClr val="151D36"/>
+            <a:srgbClr val="F8FAFC"/>
           </a:solidFill>
           <a:ln w="15240">
             <a:solidFill>
-              <a:srgbClr val="2A3B6A"/>
+              <a:srgbClr val="CBD5E1"/>
             </a:solidFill>
           </a:ln>
         </p:spPr>
@@ -7067,7 +7067,7 @@
             <a:pPr>
               <a:defRPr sz="1400" b="1">
                 <a:solidFill>
-                  <a:srgbClr val="FFC857"/>
+                  <a:srgbClr val="D97706"/>
                 </a:solidFill>
               </a:defRPr>
             </a:pPr>
@@ -7082,7 +7082,7 @@
               </a:spcBef>
               <a:defRPr sz="1150">
                 <a:solidFill>
-                  <a:srgbClr val="E2E8F0"/>
+                  <a:srgbClr val="1E293B"/>
                 </a:solidFill>
               </a:defRPr>
             </a:pPr>
@@ -7133,7 +7133,7 @@
             <a:avLst/>
           </a:prstGeom>
           <a:solidFill>
-            <a:srgbClr val="0B1020"/>
+            <a:srgbClr val="FFFFFF"/>
           </a:solidFill>
           <a:ln>
             <a:noFill/>
@@ -7176,7 +7176,7 @@
             <a:avLst/>
           </a:prstGeom>
           <a:solidFill>
-            <a:srgbClr val="26D9F1"/>
+            <a:srgbClr val="0284C7"/>
           </a:solidFill>
           <a:ln>
             <a:noFill/>
@@ -7229,7 +7229,7 @@
             <a:pPr>
               <a:defRPr sz="2600" b="1">
                 <a:solidFill>
-                  <a:srgbClr val="FFFFFF"/>
+                  <a:srgbClr val="0F172A"/>
                 </a:solidFill>
                 <a:latin typeface="Segoe UI"/>
               </a:defRPr>
@@ -7265,7 +7265,7 @@
             <a:pPr>
               <a:defRPr sz="950">
                 <a:solidFill>
-                  <a:srgbClr val="E2E8F0"/>
+                  <a:srgbClr val="64748B"/>
                 </a:solidFill>
                 <a:latin typeface="Segoe UI"/>
               </a:defRPr>
@@ -7315,11 +7315,11 @@
             <a:avLst/>
           </a:prstGeom>
           <a:solidFill>
-            <a:srgbClr val="151D36"/>
+            <a:srgbClr val="F8FAFC"/>
           </a:solidFill>
           <a:ln w="15240">
             <a:solidFill>
-              <a:srgbClr val="2A3B6A"/>
+              <a:srgbClr val="CBD5E1"/>
             </a:solidFill>
           </a:ln>
         </p:spPr>
@@ -7370,7 +7370,7 @@
             <a:pPr>
               <a:defRPr sz="1500" b="1">
                 <a:solidFill>
-                  <a:srgbClr val="26D9F1"/>
+                  <a:srgbClr val="0284C7"/>
                 </a:solidFill>
               </a:defRPr>
             </a:pPr>
@@ -7385,7 +7385,7 @@
               </a:spcBef>
               <a:defRPr sz="1200">
                 <a:solidFill>
-                  <a:srgbClr val="E2E8F0"/>
+                  <a:srgbClr val="1E293B"/>
                 </a:solidFill>
               </a:defRPr>
             </a:pPr>
@@ -7422,11 +7422,11 @@
             <a:avLst/>
           </a:prstGeom>
           <a:solidFill>
-            <a:srgbClr val="151D36"/>
+            <a:srgbClr val="F8FAFC"/>
           </a:solidFill>
           <a:ln w="15240">
             <a:solidFill>
-              <a:srgbClr val="2A3B6A"/>
+              <a:srgbClr val="CBD5E1"/>
             </a:solidFill>
           </a:ln>
         </p:spPr>
@@ -7477,7 +7477,7 @@
             <a:pPr>
               <a:defRPr sz="1500" b="1">
                 <a:solidFill>
-                  <a:srgbClr val="FFFFFF"/>
+                  <a:srgbClr val="1E40AF"/>
                 </a:solidFill>
               </a:defRPr>
             </a:pPr>
@@ -7492,7 +7492,7 @@
               </a:spcBef>
               <a:defRPr sz="1200">
                 <a:solidFill>
-                  <a:srgbClr val="E2E8F0"/>
+                  <a:srgbClr val="1E293B"/>
                 </a:solidFill>
               </a:defRPr>
             </a:pPr>
@@ -7521,11 +7521,11 @@
             <a:avLst/>
           </a:prstGeom>
           <a:solidFill>
-            <a:srgbClr val="151D36"/>
+            <a:srgbClr val="F8FAFC"/>
           </a:solidFill>
           <a:ln w="15240">
             <a:solidFill>
-              <a:srgbClr val="2A3B6A"/>
+              <a:srgbClr val="CBD5E1"/>
             </a:solidFill>
           </a:ln>
         </p:spPr>
@@ -7576,7 +7576,7 @@
             <a:pPr>
               <a:defRPr sz="1500" b="1">
                 <a:solidFill>
-                  <a:srgbClr val="FFC857"/>
+                  <a:srgbClr val="D97706"/>
                 </a:solidFill>
               </a:defRPr>
             </a:pPr>
@@ -7591,7 +7591,7 @@
               </a:spcBef>
               <a:defRPr sz="1200">
                 <a:solidFill>
-                  <a:srgbClr val="E2E8F0"/>
+                  <a:srgbClr val="1E293B"/>
                 </a:solidFill>
               </a:defRPr>
             </a:pPr>
@@ -7646,7 +7646,7 @@
             <a:avLst/>
           </a:prstGeom>
           <a:solidFill>
-            <a:srgbClr val="0B1020"/>
+            <a:srgbClr val="FFFFFF"/>
           </a:solidFill>
           <a:ln>
             <a:noFill/>
@@ -7689,7 +7689,7 @@
             <a:avLst/>
           </a:prstGeom>
           <a:solidFill>
-            <a:srgbClr val="26D9F1"/>
+            <a:srgbClr val="0284C7"/>
           </a:solidFill>
           <a:ln>
             <a:noFill/>
@@ -7742,7 +7742,7 @@
             <a:pPr>
               <a:defRPr sz="2600" b="1">
                 <a:solidFill>
-                  <a:srgbClr val="FFFFFF"/>
+                  <a:srgbClr val="0F172A"/>
                 </a:solidFill>
                 <a:latin typeface="Segoe UI"/>
               </a:defRPr>
@@ -7778,7 +7778,7 @@
             <a:pPr>
               <a:defRPr sz="950">
                 <a:solidFill>
-                  <a:srgbClr val="E2E8F0"/>
+                  <a:srgbClr val="64748B"/>
                 </a:solidFill>
                 <a:latin typeface="Segoe UI"/>
               </a:defRPr>
@@ -7804,11 +7804,11 @@
             <a:avLst/>
           </a:prstGeom>
           <a:solidFill>
-            <a:srgbClr val="151D36"/>
+            <a:srgbClr val="F8FAFC"/>
           </a:solidFill>
           <a:ln w="15240">
             <a:solidFill>
-              <a:srgbClr val="2A3B6A"/>
+              <a:srgbClr val="CBD5E1"/>
             </a:solidFill>
           </a:ln>
         </p:spPr>
@@ -7859,7 +7859,7 @@
             <a:pPr>
               <a:defRPr sz="1500" b="1">
                 <a:solidFill>
-                  <a:srgbClr val="26D9F1"/>
+                  <a:srgbClr val="0284C7"/>
                 </a:solidFill>
               </a:defRPr>
             </a:pPr>
@@ -7876,7 +7876,7 @@
             <a:r>
               <a:rPr b="1" sz="1250">
                 <a:solidFill>
-                  <a:srgbClr val="FFFFFF"/>
+                  <a:srgbClr val="0F172A"/>
                 </a:solidFill>
               </a:rPr>
               <a:t>1. Batch Ingestion: </a:t>
@@ -7884,7 +7884,7 @@
             <a:r>
               <a:rPr sz="1200">
                 <a:solidFill>
-                  <a:srgbClr val="E2E8F0"/>
+                  <a:srgbClr val="1E293B"/>
                 </a:solidFill>
               </a:rPr>
               <a:t>Mini-batch of 64 sequences (shape: [64, 32, 3]) transferred to GPU with non_blocking=True and pinned memory.</a:t>
@@ -7899,7 +7899,7 @@
             <a:r>
               <a:rPr b="1" sz="1250">
                 <a:solidFill>
-                  <a:srgbClr val="FFFFFF"/>
+                  <a:srgbClr val="0F172A"/>
                 </a:solidFill>
               </a:rPr>
               <a:t>2. Forward Propagation: </a:t>
@@ -7907,7 +7907,7 @@
             <a:r>
               <a:rPr sz="1200">
                 <a:solidFill>
-                  <a:srgbClr val="E2E8F0"/>
+                  <a:srgbClr val="1E293B"/>
                 </a:solidFill>
               </a:rPr>
               <a:t>Inputs pass through embeddings, LSTM, and heads to produce unnormalized logits: L_p [64, 128], L_d [64, 32], L_s [64, 32].</a:t>
@@ -7922,7 +7922,7 @@
             <a:r>
               <a:rPr b="1" sz="1250">
                 <a:solidFill>
-                  <a:srgbClr val="FFFFFF"/>
+                  <a:srgbClr val="0F172A"/>
                 </a:solidFill>
               </a:rPr>
               <a:t>3. Multi-Task Loss Calculation: </a:t>
@@ -7930,7 +7930,7 @@
             <a:r>
               <a:rPr sz="1200">
                 <a:solidFill>
-                  <a:srgbClr val="E2E8F0"/>
+                  <a:srgbClr val="1E293B"/>
                 </a:solidFill>
               </a:rPr>
               <a:t>Three separate cross-entropy losses are computed against target indices and summed equally: L_total = L_p + L_d + L_s.</a:t>
@@ -7945,7 +7945,7 @@
             <a:r>
               <a:rPr b="1" sz="1250">
                 <a:solidFill>
-                  <a:srgbClr val="FFFFFF"/>
+                  <a:srgbClr val="0F172A"/>
                 </a:solidFill>
               </a:rPr>
               <a:t>4. Backpropagation Through Time (BPTT): </a:t>
@@ -7953,7 +7953,7 @@
             <a:r>
               <a:rPr sz="1200">
                 <a:solidFill>
-                  <a:srgbClr val="E2E8F0"/>
+                  <a:srgbClr val="1E293B"/>
                 </a:solidFill>
               </a:rPr>
               <a:t>loss.backward() unrolls gradients backward across all 32 time steps.</a:t>
@@ -7968,7 +7968,7 @@
             <a:r>
               <a:rPr b="1" sz="1250">
                 <a:solidFill>
-                  <a:srgbClr val="FFFFFF"/>
+                  <a:srgbClr val="0F172A"/>
                 </a:solidFill>
               </a:rPr>
               <a:t>5. Gradient Clipping: </a:t>
@@ -7976,7 +7976,7 @@
             <a:r>
               <a:rPr sz="1200">
                 <a:solidFill>
-                  <a:srgbClr val="E2E8F0"/>
+                  <a:srgbClr val="1E293B"/>
                 </a:solidFill>
               </a:rPr>
               <a:t>torch.nn.utils.clip_grad_norm_(max_norm=1.0) prevents exploding gradients during sudden transitions.</a:t>
@@ -7991,7 +7991,7 @@
             <a:r>
               <a:rPr b="1" sz="1250">
                 <a:solidFill>
-                  <a:srgbClr val="FFFFFF"/>
+                  <a:srgbClr val="0F172A"/>
                 </a:solidFill>
               </a:rPr>
               <a:t>6. Parameter Update: </a:t>
@@ -7999,7 +7999,7 @@
             <a:r>
               <a:rPr sz="1200">
                 <a:solidFill>
-                  <a:srgbClr val="E2E8F0"/>
+                  <a:srgbClr val="1E293B"/>
                 </a:solidFill>
               </a:rPr>
               <a:t>Adam optimizer (lr=0.001, weight_decay=1e-5) updates all 167k parameters using running first &amp; second moments.</a:t>
@@ -8022,11 +8022,11 @@
             <a:avLst/>
           </a:prstGeom>
           <a:solidFill>
-            <a:srgbClr val="151D36"/>
+            <a:srgbClr val="F8FAFC"/>
           </a:solidFill>
           <a:ln w="15240">
             <a:solidFill>
-              <a:srgbClr val="2A3B6A"/>
+              <a:srgbClr val="CBD5E1"/>
             </a:solidFill>
           </a:ln>
         </p:spPr>
@@ -8077,7 +8077,7 @@
             <a:pPr>
               <a:defRPr sz="1500" b="1">
                 <a:solidFill>
-                  <a:srgbClr val="FFC857"/>
+                  <a:srgbClr val="D97706"/>
                 </a:solidFill>
               </a:defRPr>
             </a:pPr>
@@ -8094,7 +8094,7 @@
             <a:r>
               <a:rPr b="1" sz="1250">
                 <a:solidFill>
-                  <a:srgbClr val="FFFFFF"/>
+                  <a:srgbClr val="0F172A"/>
                 </a:solidFill>
               </a:rPr>
               <a:t>• Compute Device: </a:t>
@@ -8102,7 +8102,7 @@
             <a:r>
               <a:rPr sz="1200">
                 <a:solidFill>
-                  <a:srgbClr val="26D9F1"/>
+                  <a:srgbClr val="0284C7"/>
                 </a:solidFill>
               </a:rPr>
               <a:t>NVIDIA GeForce RTX 3050 Laptop GPU (4 GB VRAM)</a:t>
@@ -8117,7 +8117,7 @@
             <a:r>
               <a:rPr b="1" sz="1250">
                 <a:solidFill>
-                  <a:srgbClr val="FFFFFF"/>
+                  <a:srgbClr val="0F172A"/>
                 </a:solidFill>
               </a:rPr>
               <a:t>• PyTorch Environment: </a:t>
@@ -8125,7 +8125,7 @@
             <a:r>
               <a:rPr sz="1200">
                 <a:solidFill>
-                  <a:srgbClr val="26D9F1"/>
+                  <a:srgbClr val="0284C7"/>
                 </a:solidFill>
               </a:rPr>
               <a:t>PyTorch 2.13.0+cu126 (CUDA 12.6 Backend)</a:t>
@@ -8140,7 +8140,7 @@
             <a:r>
               <a:rPr b="1" sz="1250">
                 <a:solidFill>
-                  <a:srgbClr val="FFFFFF"/>
+                  <a:srgbClr val="0F172A"/>
                 </a:solidFill>
               </a:rPr>
               <a:t>• Batch Size: </a:t>
@@ -8148,7 +8148,7 @@
             <a:r>
               <a:rPr sz="1200">
                 <a:solidFill>
-                  <a:srgbClr val="26D9F1"/>
+                  <a:srgbClr val="0284C7"/>
                 </a:solidFill>
               </a:rPr>
               <a:t>64 sequences per iteration (1,562 batches / epoch)</a:t>
@@ -8163,7 +8163,7 @@
             <a:r>
               <a:rPr b="1" sz="1250">
                 <a:solidFill>
-                  <a:srgbClr val="FFFFFF"/>
+                  <a:srgbClr val="0F172A"/>
                 </a:solidFill>
               </a:rPr>
               <a:t>• Sequence Length: </a:t>
@@ -8171,7 +8171,7 @@
             <a:r>
               <a:rPr sz="1200">
                 <a:solidFill>
-                  <a:srgbClr val="26D9F1"/>
+                  <a:srgbClr val="0284C7"/>
                 </a:solidFill>
               </a:rPr>
               <a:t>32 note events (sliding window, stride = 4)</a:t>
@@ -8186,7 +8186,7 @@
             <a:r>
               <a:rPr b="1" sz="1250">
                 <a:solidFill>
-                  <a:srgbClr val="FFFFFF"/>
+                  <a:srgbClr val="0F172A"/>
                 </a:solidFill>
               </a:rPr>
               <a:t>• Optimizer: </a:t>
@@ -8194,7 +8194,7 @@
             <a:r>
               <a:rPr sz="1200">
                 <a:solidFill>
-                  <a:srgbClr val="26D9F1"/>
+                  <a:srgbClr val="0284C7"/>
                 </a:solidFill>
               </a:rPr>
               <a:t>Adam (Learning Rate = 1e-3, Weight Decay = 1e-5)</a:t>
@@ -8209,7 +8209,7 @@
             <a:r>
               <a:rPr b="1" sz="1250">
                 <a:solidFill>
-                  <a:srgbClr val="FFFFFF"/>
+                  <a:srgbClr val="0F172A"/>
                 </a:solidFill>
               </a:rPr>
               <a:t>• Loss Function: </a:t>
@@ -8217,7 +8217,7 @@
             <a:r>
               <a:rPr sz="1200">
                 <a:solidFill>
-                  <a:srgbClr val="26D9F1"/>
+                  <a:srgbClr val="0284C7"/>
                 </a:solidFill>
               </a:rPr>
               <a:t>Multi-Task Cross-Entropy (Pitch, Duration, Step)</a:t>
@@ -8232,7 +8232,7 @@
             <a:r>
               <a:rPr b="1" sz="1250">
                 <a:solidFill>
-                  <a:srgbClr val="FFFFFF"/>
+                  <a:srgbClr val="0F172A"/>
                 </a:solidFill>
               </a:rPr>
               <a:t>• Regularization: </a:t>
@@ -8240,7 +8240,7 @@
             <a:r>
               <a:rPr sz="1200">
                 <a:solidFill>
-                  <a:srgbClr val="26D9F1"/>
+                  <a:srgbClr val="0284C7"/>
                 </a:solidFill>
               </a:rPr>
               <a:t>Dropout(p=0.1) after embeddings + Gradient Clipping (1.0)</a:t>
@@ -8255,7 +8255,7 @@
             <a:r>
               <a:rPr b="1" sz="1250">
                 <a:solidFill>
-                  <a:srgbClr val="FFFFFF"/>
+                  <a:srgbClr val="0F172A"/>
                 </a:solidFill>
               </a:rPr>
               <a:t>• Throughput: </a:t>
@@ -8263,7 +8263,7 @@
             <a:r>
               <a:rPr sz="1200">
                 <a:solidFill>
-                  <a:srgbClr val="26D9F1"/>
+                  <a:srgbClr val="0284C7"/>
                 </a:solidFill>
               </a:rPr>
               <a:t>~91 batches/sec (17.2 seconds per epoch)</a:t>
@@ -8304,7 +8304,7 @@
             <a:avLst/>
           </a:prstGeom>
           <a:solidFill>
-            <a:srgbClr val="0B1020"/>
+            <a:srgbClr val="FFFFFF"/>
           </a:solidFill>
           <a:ln>
             <a:noFill/>
@@ -8347,7 +8347,7 @@
             <a:avLst/>
           </a:prstGeom>
           <a:solidFill>
-            <a:srgbClr val="26D9F1"/>
+            <a:srgbClr val="0284C7"/>
           </a:solidFill>
           <a:ln>
             <a:noFill/>
@@ -8400,7 +8400,7 @@
             <a:pPr>
               <a:defRPr sz="2600" b="1">
                 <a:solidFill>
-                  <a:srgbClr val="FFFFFF"/>
+                  <a:srgbClr val="0F172A"/>
                 </a:solidFill>
                 <a:latin typeface="Segoe UI"/>
               </a:defRPr>
@@ -8436,7 +8436,7 @@
             <a:pPr>
               <a:defRPr sz="950">
                 <a:solidFill>
-                  <a:srgbClr val="E2E8F0"/>
+                  <a:srgbClr val="64748B"/>
                 </a:solidFill>
                 <a:latin typeface="Segoe UI"/>
               </a:defRPr>
@@ -8486,11 +8486,11 @@
             <a:avLst/>
           </a:prstGeom>
           <a:solidFill>
-            <a:srgbClr val="151D36"/>
+            <a:srgbClr val="F8FAFC"/>
           </a:solidFill>
           <a:ln w="15240">
             <a:solidFill>
-              <a:srgbClr val="2A3B6A"/>
+              <a:srgbClr val="CBD5E1"/>
             </a:solidFill>
           </a:ln>
         </p:spPr>
@@ -8541,7 +8541,7 @@
             <a:pPr>
               <a:defRPr sz="1500" b="1">
                 <a:solidFill>
-                  <a:srgbClr val="22C55E"/>
+                  <a:srgbClr val="16A34A"/>
                 </a:solidFill>
               </a:defRPr>
             </a:pPr>
@@ -8556,7 +8556,7 @@
               </a:spcBef>
               <a:defRPr sz="1200">
                 <a:solidFill>
-                  <a:srgbClr val="E2E8F0"/>
+                  <a:srgbClr val="1E293B"/>
                 </a:solidFill>
               </a:defRPr>
             </a:pPr>
@@ -8589,11 +8589,11 @@
             <a:avLst/>
           </a:prstGeom>
           <a:solidFill>
-            <a:srgbClr val="151D36"/>
+            <a:srgbClr val="F8FAFC"/>
           </a:solidFill>
           <a:ln w="15240">
             <a:solidFill>
-              <a:srgbClr val="2A3B6A"/>
+              <a:srgbClr val="CBD5E1"/>
             </a:solidFill>
           </a:ln>
         </p:spPr>
@@ -8644,7 +8644,7 @@
             <a:pPr>
               <a:defRPr sz="1500" b="1">
                 <a:solidFill>
-                  <a:srgbClr val="26D9F1"/>
+                  <a:srgbClr val="0284C7"/>
                 </a:solidFill>
               </a:defRPr>
             </a:pPr>
@@ -8659,7 +8659,7 @@
               </a:spcBef>
               <a:defRPr sz="1200">
                 <a:solidFill>
-                  <a:srgbClr val="E2E8F0"/>
+                  <a:srgbClr val="1E293B"/>
                 </a:solidFill>
               </a:defRPr>
             </a:pPr>
@@ -8688,11 +8688,11 @@
             <a:avLst/>
           </a:prstGeom>
           <a:solidFill>
-            <a:srgbClr val="151D36"/>
+            <a:srgbClr val="F8FAFC"/>
           </a:solidFill>
           <a:ln w="15240">
             <a:solidFill>
-              <a:srgbClr val="2A3B6A"/>
+              <a:srgbClr val="CBD5E1"/>
             </a:solidFill>
           </a:ln>
         </p:spPr>
@@ -8743,7 +8743,7 @@
             <a:pPr>
               <a:defRPr sz="1500" b="1">
                 <a:solidFill>
-                  <a:srgbClr val="FFC857"/>
+                  <a:srgbClr val="D97706"/>
                 </a:solidFill>
               </a:defRPr>
             </a:pPr>
@@ -8758,7 +8758,7 @@
               </a:spcBef>
               <a:defRPr sz="1200">
                 <a:solidFill>
-                  <a:srgbClr val="E2E8F0"/>
+                  <a:srgbClr val="1E293B"/>
                 </a:solidFill>
               </a:defRPr>
             </a:pPr>
@@ -8805,7 +8805,7 @@
             <a:avLst/>
           </a:prstGeom>
           <a:solidFill>
-            <a:srgbClr val="0B1020"/>
+            <a:srgbClr val="FFFFFF"/>
           </a:solidFill>
           <a:ln>
             <a:noFill/>
@@ -8848,7 +8848,7 @@
             <a:avLst/>
           </a:prstGeom>
           <a:solidFill>
-            <a:srgbClr val="26D9F1"/>
+            <a:srgbClr val="0284C7"/>
           </a:solidFill>
           <a:ln>
             <a:noFill/>
@@ -8901,7 +8901,7 @@
             <a:pPr>
               <a:defRPr sz="2600" b="1">
                 <a:solidFill>
-                  <a:srgbClr val="FFFFFF"/>
+                  <a:srgbClr val="0F172A"/>
                 </a:solidFill>
                 <a:latin typeface="Segoe UI"/>
               </a:defRPr>
@@ -8937,7 +8937,7 @@
             <a:pPr>
               <a:defRPr sz="950">
                 <a:solidFill>
-                  <a:srgbClr val="E2E8F0"/>
+                  <a:srgbClr val="64748B"/>
                 </a:solidFill>
                 <a:latin typeface="Segoe UI"/>
               </a:defRPr>
@@ -8963,11 +8963,11 @@
             <a:avLst/>
           </a:prstGeom>
           <a:solidFill>
-            <a:srgbClr val="151D36"/>
+            <a:srgbClr val="F8FAFC"/>
           </a:solidFill>
           <a:ln w="15240">
             <a:solidFill>
-              <a:srgbClr val="2A3B6A"/>
+              <a:srgbClr val="CBD5E1"/>
             </a:solidFill>
           </a:ln>
         </p:spPr>
@@ -9018,7 +9018,7 @@
             <a:pPr>
               <a:defRPr sz="1500" b="1">
                 <a:solidFill>
-                  <a:srgbClr val="26D9F1"/>
+                  <a:srgbClr val="0284C7"/>
                 </a:solidFill>
               </a:defRPr>
             </a:pPr>
@@ -9035,7 +9035,7 @@
             <a:r>
               <a:rPr b="1" sz="1300">
                 <a:solidFill>
-                  <a:srgbClr val="FFC857"/>
+                  <a:srgbClr val="D97706"/>
                 </a:solidFill>
                 <a:latin typeface="Consolas"/>
               </a:rPr>
@@ -9044,7 +9044,7 @@
             <a:r>
               <a:rPr sz="1200">
                 <a:solidFill>
-                  <a:srgbClr val="E2E8F0"/>
+                  <a:srgbClr val="1E293B"/>
                 </a:solidFill>
               </a:rPr>
               <a:t>Complete dictionary of all learned PyTorch tensor weight matrices (167,104 parameters).</a:t>
@@ -9059,7 +9059,7 @@
             <a:r>
               <a:rPr b="1" sz="1300">
                 <a:solidFill>
-                  <a:srgbClr val="FFC857"/>
+                  <a:srgbClr val="D97706"/>
                 </a:solidFill>
                 <a:latin typeface="Consolas"/>
               </a:rPr>
@@ -9068,7 +9068,7 @@
             <a:r>
               <a:rPr sz="1200">
                 <a:solidFill>
-                  <a:srgbClr val="E2E8F0"/>
+                  <a:srgbClr val="1E293B"/>
                 </a:solidFill>
               </a:rPr>
               <a:t>Running Adam first (m) and second (v) gradient momentum vectors for seamless training resumption.</a:t>
@@ -9083,7 +9083,7 @@
             <a:r>
               <a:rPr b="1" sz="1300">
                 <a:solidFill>
-                  <a:srgbClr val="FFC857"/>
+                  <a:srgbClr val="D97706"/>
                 </a:solidFill>
                 <a:latin typeface="Consolas"/>
               </a:rPr>
@@ -9092,7 +9092,7 @@
             <a:r>
               <a:rPr sz="1200">
                 <a:solidFill>
-                  <a:srgbClr val="E2E8F0"/>
+                  <a:srgbClr val="1E293B"/>
                 </a:solidFill>
               </a:rPr>
               <a:t>Integer recording the exact completed epoch index (e.g. Epoch 7).</a:t>
@@ -9107,7 +9107,7 @@
             <a:r>
               <a:rPr b="1" sz="1300">
                 <a:solidFill>
-                  <a:srgbClr val="FFC857"/>
+                  <a:srgbClr val="D97706"/>
                 </a:solidFill>
                 <a:latin typeface="Consolas"/>
               </a:rPr>
@@ -9116,7 +9116,7 @@
             <a:r>
               <a:rPr sz="1200">
                 <a:solidFill>
-                  <a:srgbClr val="E2E8F0"/>
+                  <a:srgbClr val="1E293B"/>
                 </a:solidFill>
               </a:rPr>
               <a:t>Floating-point loss values at checkpoint creation (val_loss: 5.9151).</a:t>
@@ -9131,7 +9131,7 @@
             <a:r>
               <a:rPr b="1" sz="1300">
                 <a:solidFill>
-                  <a:srgbClr val="FFC857"/>
+                  <a:srgbClr val="D97706"/>
                 </a:solidFill>
                 <a:latin typeface="Consolas"/>
               </a:rPr>
@@ -9140,7 +9140,7 @@
             <a:r>
               <a:rPr sz="1200">
                 <a:solidFill>
-                  <a:srgbClr val="E2E8F0"/>
+                  <a:srgbClr val="1E293B"/>
                 </a:solidFill>
               </a:rPr>
               <a:t>Multi-task breakdown dictionary (loss_pitch, loss_dur, loss_step).</a:t>
@@ -9155,7 +9155,7 @@
             <a:r>
               <a:rPr b="1" sz="1300">
                 <a:solidFill>
-                  <a:srgbClr val="FFC857"/>
+                  <a:srgbClr val="D97706"/>
                 </a:solidFill>
                 <a:latin typeface="Consolas"/>
               </a:rPr>
@@ -9164,7 +9164,7 @@
             <a:r>
               <a:rPr sz="1200">
                 <a:solidFill>
-                  <a:srgbClr val="E2E8F0"/>
+                  <a:srgbClr val="1E293B"/>
                 </a:solidFill>
               </a:rPr>
               <a:t>Serialized dictionary of all hyperparameters (hidden_dim=128, seq_length=32) for zero-mismatch reloading.</a:t>
@@ -9187,11 +9187,11 @@
             <a:avLst/>
           </a:prstGeom>
           <a:solidFill>
-            <a:srgbClr val="151D36"/>
+            <a:srgbClr val="F8FAFC"/>
           </a:solidFill>
           <a:ln w="15240">
             <a:solidFill>
-              <a:srgbClr val="2A3B6A"/>
+              <a:srgbClr val="CBD5E1"/>
             </a:solidFill>
           </a:ln>
         </p:spPr>
@@ -9242,7 +9242,7 @@
             <a:pPr>
               <a:defRPr sz="1500" b="1">
                 <a:solidFill>
-                  <a:srgbClr val="FFC857"/>
+                  <a:srgbClr val="D97706"/>
                 </a:solidFill>
               </a:defRPr>
             </a:pPr>
@@ -9259,7 +9259,7 @@
             <a:r>
               <a:rPr b="1" sz="1350">
                 <a:solidFill>
-                  <a:srgbClr val="22C55E"/>
+                  <a:srgbClr val="16A34A"/>
                 </a:solidFill>
                 <a:latin typeface="Consolas"/>
               </a:rPr>
@@ -9269,7 +9269,7 @@
             <a:r>
               <a:rPr sz="1200">
                 <a:solidFill>
-                  <a:srgbClr val="E2E8F0"/>
+                  <a:srgbClr val="1E293B"/>
                 </a:solidFill>
               </a:rPr>
               <a:t>Epoch 7 Best Model — Val Loss: 5.9151 | Trained on 962 files, 100k sequences. Primary deployment checkpoint.</a:t>
@@ -9284,7 +9284,7 @@
             <a:r>
               <a:rPr b="1" sz="1350">
                 <a:solidFill>
-                  <a:srgbClr val="FFFFFF"/>
+                  <a:srgbClr val="1E40AF"/>
                 </a:solidFill>
                 <a:latin typeface="Consolas"/>
               </a:rPr>
@@ -9294,7 +9294,7 @@
             <a:r>
               <a:rPr sz="1200">
                 <a:solidFill>
-                  <a:srgbClr val="E2E8F0"/>
+                  <a:srgbClr val="1E293B"/>
                 </a:solidFill>
               </a:rPr>
               <a:t>Epoch 15 Latest Model — Val Loss: 6.0386 | Final epoch before early stopping. Preserved for training recovery.</a:t>
@@ -9309,7 +9309,7 @@
             <a:r>
               <a:rPr b="1" sz="1350">
                 <a:solidFill>
-                  <a:srgbClr val="E2E8F0"/>
+                  <a:srgbClr val="475569"/>
                 </a:solidFill>
                 <a:latin typeface="Consolas"/>
               </a:rPr>
@@ -9319,7 +9319,7 @@
             <a:r>
               <a:rPr sz="1200">
                 <a:solidFill>
-                  <a:srgbClr val="E2E8F0"/>
+                  <a:srgbClr val="1E293B"/>
                 </a:solidFill>
               </a:rPr>
               <a:t>Epoch 4 Baseline Model — Val Loss: 6.1791 | Original 13-performance model safely preserved for comparative benchmark.</a:t>
@@ -9334,7 +9334,7 @@
             <a:r>
               <a:rPr b="1" sz="1350">
                 <a:solidFill>
-                  <a:srgbClr val="26D9F1"/>
+                  <a:srgbClr val="0284C7"/>
                 </a:solidFill>
                 <a:latin typeface="Consolas"/>
               </a:rPr>
@@ -9344,7 +9344,7 @@
             <a:r>
               <a:rPr sz="1200">
                 <a:solidFill>
-                  <a:srgbClr val="E2E8F0"/>
+                  <a:srgbClr val="1E293B"/>
                 </a:solidFill>
               </a:rPr>
               <a:t>Persistent Training Record — Complete timestamped log of all batches, running averages, and validation metrics.</a:t>
@@ -9385,7 +9385,7 @@
             <a:avLst/>
           </a:prstGeom>
           <a:solidFill>
-            <a:srgbClr val="0B1020"/>
+            <a:srgbClr val="FFFFFF"/>
           </a:solidFill>
           <a:ln>
             <a:noFill/>
@@ -9428,7 +9428,7 @@
             <a:avLst/>
           </a:prstGeom>
           <a:solidFill>
-            <a:srgbClr val="26D9F1"/>
+            <a:srgbClr val="0284C7"/>
           </a:solidFill>
           <a:ln>
             <a:noFill/>
@@ -9481,7 +9481,7 @@
             <a:pPr>
               <a:defRPr sz="2600" b="1">
                 <a:solidFill>
-                  <a:srgbClr val="FFFFFF"/>
+                  <a:srgbClr val="0F172A"/>
                 </a:solidFill>
                 <a:latin typeface="Segoe UI"/>
               </a:defRPr>
@@ -9517,7 +9517,7 @@
             <a:pPr>
               <a:defRPr sz="950">
                 <a:solidFill>
-                  <a:srgbClr val="E2E8F0"/>
+                  <a:srgbClr val="64748B"/>
                 </a:solidFill>
                 <a:latin typeface="Segoe UI"/>
               </a:defRPr>
@@ -9567,11 +9567,11 @@
             <a:avLst/>
           </a:prstGeom>
           <a:solidFill>
-            <a:srgbClr val="151D36"/>
+            <a:srgbClr val="F8FAFC"/>
           </a:solidFill>
           <a:ln w="15240">
             <a:solidFill>
-              <a:srgbClr val="2A3B6A"/>
+              <a:srgbClr val="CBD5E1"/>
             </a:solidFill>
           </a:ln>
         </p:spPr>
@@ -9622,7 +9622,7 @@
             <a:pPr>
               <a:defRPr sz="1500" b="1">
                 <a:solidFill>
-                  <a:srgbClr val="26D9F1"/>
+                  <a:srgbClr val="0284C7"/>
                 </a:solidFill>
               </a:defRPr>
             </a:pPr>
@@ -9637,7 +9637,7 @@
               </a:spcBef>
               <a:defRPr sz="1200">
                 <a:solidFill>
-                  <a:srgbClr val="E2E8F0"/>
+                  <a:srgbClr val="1E293B"/>
                 </a:solidFill>
               </a:defRPr>
             </a:pPr>
@@ -9670,11 +9670,11 @@
             <a:avLst/>
           </a:prstGeom>
           <a:solidFill>
-            <a:srgbClr val="151D36"/>
+            <a:srgbClr val="F8FAFC"/>
           </a:solidFill>
           <a:ln w="15240">
             <a:solidFill>
-              <a:srgbClr val="2A3B6A"/>
+              <a:srgbClr val="CBD5E1"/>
             </a:solidFill>
           </a:ln>
         </p:spPr>
@@ -9725,7 +9725,7 @@
             <a:pPr>
               <a:defRPr sz="1500" b="1">
                 <a:solidFill>
-                  <a:srgbClr val="FFC857"/>
+                  <a:srgbClr val="D97706"/>
                 </a:solidFill>
               </a:defRPr>
             </a:pPr>
@@ -9740,7 +9740,7 @@
               </a:spcBef>
               <a:defRPr sz="1200">
                 <a:solidFill>
-                  <a:srgbClr val="E2E8F0"/>
+                  <a:srgbClr val="1E293B"/>
                 </a:solidFill>
               </a:defRPr>
             </a:pPr>
@@ -9769,11 +9769,11 @@
             <a:avLst/>
           </a:prstGeom>
           <a:solidFill>
-            <a:srgbClr val="151D36"/>
+            <a:srgbClr val="F8FAFC"/>
           </a:solidFill>
           <a:ln w="15240">
             <a:solidFill>
-              <a:srgbClr val="2A3B6A"/>
+              <a:srgbClr val="CBD5E1"/>
             </a:solidFill>
           </a:ln>
         </p:spPr>
@@ -9824,7 +9824,7 @@
             <a:pPr>
               <a:defRPr sz="1500" b="1">
                 <a:solidFill>
-                  <a:srgbClr val="FFFFFF"/>
+                  <a:srgbClr val="1E40AF"/>
                 </a:solidFill>
               </a:defRPr>
             </a:pPr>
@@ -9839,7 +9839,7 @@
               </a:spcBef>
               <a:defRPr sz="1200">
                 <a:solidFill>
-                  <a:srgbClr val="E2E8F0"/>
+                  <a:srgbClr val="1E293B"/>
                 </a:solidFill>
               </a:defRPr>
             </a:pPr>
@@ -9886,7 +9886,7 @@
             <a:avLst/>
           </a:prstGeom>
           <a:solidFill>
-            <a:srgbClr val="0B1020"/>
+            <a:srgbClr val="FFFFFF"/>
           </a:solidFill>
           <a:ln>
             <a:noFill/>
@@ -9929,7 +9929,7 @@
             <a:avLst/>
           </a:prstGeom>
           <a:solidFill>
-            <a:srgbClr val="26D9F1"/>
+            <a:srgbClr val="0284C7"/>
           </a:solidFill>
           <a:ln>
             <a:noFill/>
@@ -9982,7 +9982,7 @@
             <a:pPr>
               <a:defRPr sz="2600" b="1">
                 <a:solidFill>
-                  <a:srgbClr val="FFFFFF"/>
+                  <a:srgbClr val="0F172A"/>
                 </a:solidFill>
                 <a:latin typeface="Segoe UI"/>
               </a:defRPr>
@@ -10018,7 +10018,7 @@
             <a:pPr>
               <a:defRPr sz="950">
                 <a:solidFill>
-                  <a:srgbClr val="E2E8F0"/>
+                  <a:srgbClr val="64748B"/>
                 </a:solidFill>
                 <a:latin typeface="Segoe UI"/>
               </a:defRPr>
@@ -10068,11 +10068,11 @@
             <a:avLst/>
           </a:prstGeom>
           <a:solidFill>
-            <a:srgbClr val="151D36"/>
+            <a:srgbClr val="F8FAFC"/>
           </a:solidFill>
           <a:ln w="15240">
             <a:solidFill>
-              <a:srgbClr val="2A3B6A"/>
+              <a:srgbClr val="CBD5E1"/>
             </a:solidFill>
           </a:ln>
         </p:spPr>
@@ -10123,7 +10123,7 @@
             <a:pPr>
               <a:defRPr sz="1500" b="1">
                 <a:solidFill>
-                  <a:srgbClr val="26D9F1"/>
+                  <a:srgbClr val="0284C7"/>
                 </a:solidFill>
               </a:defRPr>
             </a:pPr>
@@ -10138,7 +10138,7 @@
               </a:spcBef>
               <a:defRPr sz="1200">
                 <a:solidFill>
-                  <a:srgbClr val="E2E8F0"/>
+                  <a:srgbClr val="1E293B"/>
                 </a:solidFill>
               </a:defRPr>
             </a:pPr>
@@ -10171,11 +10171,11 @@
             <a:avLst/>
           </a:prstGeom>
           <a:solidFill>
-            <a:srgbClr val="151D36"/>
+            <a:srgbClr val="F8FAFC"/>
           </a:solidFill>
           <a:ln w="15240">
             <a:solidFill>
-              <a:srgbClr val="2A3B6A"/>
+              <a:srgbClr val="CBD5E1"/>
             </a:solidFill>
           </a:ln>
         </p:spPr>
@@ -10226,7 +10226,7 @@
             <a:pPr>
               <a:defRPr sz="1500" b="1">
                 <a:solidFill>
-                  <a:srgbClr val="FFC857"/>
+                  <a:srgbClr val="D97706"/>
                 </a:solidFill>
               </a:defRPr>
             </a:pPr>
@@ -10241,7 +10241,7 @@
               </a:spcBef>
               <a:defRPr sz="1200">
                 <a:solidFill>
-                  <a:srgbClr val="E2E8F0"/>
+                  <a:srgbClr val="1E293B"/>
                 </a:solidFill>
               </a:defRPr>
             </a:pPr>
@@ -10274,11 +10274,11 @@
             <a:avLst/>
           </a:prstGeom>
           <a:solidFill>
-            <a:srgbClr val="151D36"/>
+            <a:srgbClr val="F8FAFC"/>
           </a:solidFill>
           <a:ln w="15240">
             <a:solidFill>
-              <a:srgbClr val="2A3B6A"/>
+              <a:srgbClr val="CBD5E1"/>
             </a:solidFill>
           </a:ln>
         </p:spPr>
@@ -10329,7 +10329,7 @@
             <a:pPr>
               <a:defRPr sz="1500" b="1">
                 <a:solidFill>
-                  <a:srgbClr val="FFFFFF"/>
+                  <a:srgbClr val="1E40AF"/>
                 </a:solidFill>
               </a:defRPr>
             </a:pPr>
@@ -10344,7 +10344,7 @@
               </a:spcBef>
               <a:defRPr sz="1200">
                 <a:solidFill>
-                  <a:srgbClr val="E2E8F0"/>
+                  <a:srgbClr val="1E293B"/>
                 </a:solidFill>
               </a:defRPr>
             </a:pPr>
@@ -10391,7 +10391,7 @@
             <a:avLst/>
           </a:prstGeom>
           <a:solidFill>
-            <a:srgbClr val="0B1020"/>
+            <a:srgbClr val="FFFFFF"/>
           </a:solidFill>
           <a:ln>
             <a:noFill/>
@@ -10434,7 +10434,7 @@
             <a:avLst/>
           </a:prstGeom>
           <a:solidFill>
-            <a:srgbClr val="26D9F1"/>
+            <a:srgbClr val="0284C7"/>
           </a:solidFill>
           <a:ln>
             <a:noFill/>
@@ -10487,7 +10487,7 @@
             <a:pPr>
               <a:defRPr sz="2600" b="1">
                 <a:solidFill>
-                  <a:srgbClr val="FFFFFF"/>
+                  <a:srgbClr val="0F172A"/>
                 </a:solidFill>
                 <a:latin typeface="Segoe UI"/>
               </a:defRPr>
@@ -10523,7 +10523,7 @@
             <a:pPr>
               <a:defRPr sz="950">
                 <a:solidFill>
-                  <a:srgbClr val="E2E8F0"/>
+                  <a:srgbClr val="64748B"/>
                 </a:solidFill>
                 <a:latin typeface="Segoe UI"/>
               </a:defRPr>
@@ -10549,11 +10549,11 @@
             <a:avLst/>
           </a:prstGeom>
           <a:solidFill>
-            <a:srgbClr val="151D36"/>
+            <a:srgbClr val="F8FAFC"/>
           </a:solidFill>
           <a:ln w="15240">
             <a:solidFill>
-              <a:srgbClr val="2A3B6A"/>
+              <a:srgbClr val="CBD5E1"/>
             </a:solidFill>
           </a:ln>
         </p:spPr>
@@ -10604,7 +10604,7 @@
             <a:pPr>
               <a:defRPr sz="1600" b="1">
                 <a:solidFill>
-                  <a:srgbClr val="26D9F1"/>
+                  <a:srgbClr val="0284C7"/>
                 </a:solidFill>
               </a:defRPr>
             </a:pPr>
@@ -10621,7 +10621,7 @@
             <a:r>
               <a:rPr b="1" sz="1350">
                 <a:solidFill>
-                  <a:srgbClr val="FFFFFF"/>
+                  <a:srgbClr val="0F172A"/>
                 </a:solidFill>
               </a:rPr>
               <a:t>• Temporal Musical Dependencies:</a:t>
@@ -10629,7 +10629,7 @@
             <a:r>
               <a:rPr sz="1300">
                 <a:solidFill>
-                  <a:srgbClr val="E2E8F0"/>
+                  <a:srgbClr val="1E293B"/>
                 </a:solidFill>
               </a:rPr>
               <a:t> Piano music consists of chronologically ordered note onsets. A note's harmonic and rhythmic meaning depends strictly on prior musical context.</a:t>
@@ -10644,7 +10644,7 @@
             <a:r>
               <a:rPr b="1" sz="1350">
                 <a:solidFill>
-                  <a:srgbClr val="FFFFFF"/>
+                  <a:srgbClr val="0F172A"/>
                 </a:solidFill>
               </a:rPr>
               <a:t>• Multi-Dimensional Event Complexity:</a:t>
@@ -10652,7 +10652,7 @@
             <a:r>
               <a:rPr sz="1300">
                 <a:solidFill>
-                  <a:srgbClr val="E2E8F0"/>
+                  <a:srgbClr val="1E293B"/>
                 </a:solidFill>
               </a:rPr>
               <a:t> Music cannot be modeled by pitch alone. Each note requires pitch (0–127), duration (how long it rings), and step time (interval until next note onset).</a:t>
@@ -10667,7 +10667,7 @@
             <a:r>
               <a:rPr b="1" sz="1350">
                 <a:solidFill>
-                  <a:srgbClr val="FFFFFF"/>
+                  <a:srgbClr val="0F172A"/>
                 </a:solidFill>
               </a:rPr>
               <a:t>• Discrete Symbolic vs. Waveform Audio:</a:t>
@@ -10675,7 +10675,7 @@
             <a:r>
               <a:rPr sz="1300">
                 <a:solidFill>
-                  <a:srgbClr val="E2E8F0"/>
+                  <a:srgbClr val="1E293B"/>
                 </a:solidFill>
               </a:rPr>
               <a:t> Modeling raw 44.1 kHz waveforms requires 44,100 samples/sec, creating intractable context windows. Symbolic modeling captures structure efficiently.</a:t>
@@ -10690,7 +10690,7 @@
             <a:r>
               <a:rPr b="1" sz="1350">
                 <a:solidFill>
-                  <a:srgbClr val="FFFFFF"/>
+                  <a:srgbClr val="0F172A"/>
                 </a:solidFill>
               </a:rPr>
               <a:t>• Autoregressive Generation:</a:t>
@@ -10698,7 +10698,7 @@
             <a:r>
               <a:rPr sz="1300">
                 <a:solidFill>
-                  <a:srgbClr val="E2E8F0"/>
+                  <a:srgbClr val="1E293B"/>
                 </a:solidFill>
               </a:rPr>
               <a:t> Generating continuous coherent music requires iteratively feeding predicted outputs back as inputs without compounding catastrophic drift.</a:t>
@@ -10721,11 +10721,11 @@
             <a:avLst/>
           </a:prstGeom>
           <a:solidFill>
-            <a:srgbClr val="151D36"/>
+            <a:srgbClr val="F8FAFC"/>
           </a:solidFill>
           <a:ln w="15240">
             <a:solidFill>
-              <a:srgbClr val="2A3B6A"/>
+              <a:srgbClr val="CBD5E1"/>
             </a:solidFill>
           </a:ln>
         </p:spPr>
@@ -10776,7 +10776,7 @@
             <a:pPr>
               <a:defRPr sz="1600" b="1">
                 <a:solidFill>
-                  <a:srgbClr val="FFC857"/>
+                  <a:srgbClr val="D97706"/>
                 </a:solidFill>
               </a:defRPr>
             </a:pPr>
@@ -10793,7 +10793,7 @@
             <a:r>
               <a:rPr b="1" sz="1350">
                 <a:solidFill>
-                  <a:srgbClr val="FFFFFF"/>
+                  <a:srgbClr val="0F172A"/>
                 </a:solidFill>
               </a:rPr>
               <a:t>✓ Full MAESTRO Ingestion:</a:t>
@@ -10801,7 +10801,7 @@
             <a:r>
               <a:rPr sz="1300">
                 <a:solidFill>
-                  <a:srgbClr val="E2E8F0"/>
+                  <a:srgbClr val="1E293B"/>
                 </a:solidFill>
               </a:rPr>
               <a:t> Build a robust parser in melodyloop/data.py extracting chronological events from Yamaha Disklavier competition performances.</a:t>
@@ -10816,7 +10816,7 @@
             <a:r>
               <a:rPr b="1" sz="1350">
                 <a:solidFill>
-                  <a:srgbClr val="FFFFFF"/>
+                  <a:srgbClr val="0F172A"/>
                 </a:solidFill>
               </a:rPr>
               <a:t>✓ End-to-End PyTorch Network:</a:t>
@@ -10824,7 +10824,7 @@
             <a:r>
               <a:rPr sz="1300">
                 <a:solidFill>
-                  <a:srgbClr val="E2E8F0"/>
+                  <a:srgbClr val="1E293B"/>
                 </a:solidFill>
               </a:rPr>
               <a:t> Implement MelodyLSTM with parallel token embeddings (pitch, duration, step) and decoupled multi-task prediction heads (167k params).</a:t>
@@ -10839,7 +10839,7 @@
             <a:r>
               <a:rPr b="1" sz="1350">
                 <a:solidFill>
-                  <a:srgbClr val="FFFFFF"/>
+                  <a:srgbClr val="0F172A"/>
                 </a:solidFill>
               </a:rPr>
               <a:t>✓ Overfitting &amp; Checkpoint Control:</a:t>
@@ -10847,7 +10847,7 @@
             <a:r>
               <a:rPr sz="1300">
                 <a:solidFill>
-                  <a:srgbClr val="E2E8F0"/>
+                  <a:srgbClr val="1E293B"/>
                 </a:solidFill>
               </a:rPr>
               <a:t> Train from scratch with Adam and gradient clipping, selecting the epoch 7 validation minimum (5.9151) via automated early stopping.</a:t>
@@ -10862,7 +10862,7 @@
             <a:r>
               <a:rPr b="1" sz="1350">
                 <a:solidFill>
-                  <a:srgbClr val="FFFFFF"/>
+                  <a:srgbClr val="0F172A"/>
                 </a:solidFill>
               </a:rPr>
               <a:t>✓ Interactive Local Synthesis:</a:t>
@@ -10870,7 +10870,7 @@
             <a:r>
               <a:rPr sz="1300">
                 <a:solidFill>
-                  <a:srgbClr val="E2E8F0"/>
+                  <a:srgbClr val="1E293B"/>
                 </a:solidFill>
               </a:rPr>
               <a:t> Provide temperature &amp; Top-K sampling with instant DSP additive audio synthesis and MIDI export in a Streamlit web app.</a:t>
@@ -10911,7 +10911,7 @@
             <a:avLst/>
           </a:prstGeom>
           <a:solidFill>
-            <a:srgbClr val="0B1020"/>
+            <a:srgbClr val="FFFFFF"/>
           </a:solidFill>
           <a:ln>
             <a:noFill/>
@@ -10954,7 +10954,7 @@
             <a:avLst/>
           </a:prstGeom>
           <a:solidFill>
-            <a:srgbClr val="26D9F1"/>
+            <a:srgbClr val="0284C7"/>
           </a:solidFill>
           <a:ln>
             <a:noFill/>
@@ -11007,7 +11007,7 @@
             <a:pPr>
               <a:defRPr sz="2600" b="1">
                 <a:solidFill>
-                  <a:srgbClr val="FFFFFF"/>
+                  <a:srgbClr val="0F172A"/>
                 </a:solidFill>
                 <a:latin typeface="Segoe UI"/>
               </a:defRPr>
@@ -11043,7 +11043,7 @@
             <a:pPr>
               <a:defRPr sz="950">
                 <a:solidFill>
-                  <a:srgbClr val="E2E8F0"/>
+                  <a:srgbClr val="64748B"/>
                 </a:solidFill>
                 <a:latin typeface="Segoe UI"/>
               </a:defRPr>
@@ -11093,11 +11093,11 @@
             <a:avLst/>
           </a:prstGeom>
           <a:solidFill>
-            <a:srgbClr val="151D36"/>
+            <a:srgbClr val="F8FAFC"/>
           </a:solidFill>
           <a:ln w="15240">
             <a:solidFill>
-              <a:srgbClr val="2A3B6A"/>
+              <a:srgbClr val="CBD5E1"/>
             </a:solidFill>
           </a:ln>
         </p:spPr>
@@ -11148,7 +11148,7 @@
             <a:pPr>
               <a:defRPr sz="1400" b="1">
                 <a:solidFill>
-                  <a:srgbClr val="26D9F1"/>
+                  <a:srgbClr val="0284C7"/>
                 </a:solidFill>
               </a:defRPr>
             </a:pPr>
@@ -11163,7 +11163,7 @@
               </a:spcBef>
               <a:defRPr sz="1200" b="1">
                 <a:solidFill>
-                  <a:srgbClr val="FFFFFF"/>
+                  <a:srgbClr val="0F172A"/>
                 </a:solidFill>
               </a:defRPr>
             </a:pPr>
@@ -11178,7 +11178,7 @@
               </a:spcBef>
               <a:defRPr sz="1150">
                 <a:solidFill>
-                  <a:srgbClr val="E2E8F0"/>
+                  <a:srgbClr val="1E293B"/>
                 </a:solidFill>
               </a:defRPr>
             </a:pPr>
@@ -11203,11 +11203,11 @@
             <a:avLst/>
           </a:prstGeom>
           <a:solidFill>
-            <a:srgbClr val="151D36"/>
+            <a:srgbClr val="F8FAFC"/>
           </a:solidFill>
           <a:ln w="15240">
             <a:solidFill>
-              <a:srgbClr val="2A3B6A"/>
+              <a:srgbClr val="CBD5E1"/>
             </a:solidFill>
           </a:ln>
         </p:spPr>
@@ -11258,7 +11258,7 @@
             <a:pPr>
               <a:defRPr sz="1400" b="1">
                 <a:solidFill>
-                  <a:srgbClr val="FFFFFF"/>
+                  <a:srgbClr val="1E40AF"/>
                 </a:solidFill>
               </a:defRPr>
             </a:pPr>
@@ -11273,7 +11273,7 @@
               </a:spcBef>
               <a:defRPr sz="1200" b="1">
                 <a:solidFill>
-                  <a:srgbClr val="FFFFFF"/>
+                  <a:srgbClr val="0F172A"/>
                 </a:solidFill>
               </a:defRPr>
             </a:pPr>
@@ -11288,7 +11288,7 @@
               </a:spcBef>
               <a:defRPr sz="1150">
                 <a:solidFill>
-                  <a:srgbClr val="E2E8F0"/>
+                  <a:srgbClr val="1E293B"/>
                 </a:solidFill>
               </a:defRPr>
             </a:pPr>
@@ -11313,11 +11313,11 @@
             <a:avLst/>
           </a:prstGeom>
           <a:solidFill>
-            <a:srgbClr val="151D36"/>
+            <a:srgbClr val="F8FAFC"/>
           </a:solidFill>
           <a:ln w="15240">
             <a:solidFill>
-              <a:srgbClr val="2A3B6A"/>
+              <a:srgbClr val="CBD5E1"/>
             </a:solidFill>
           </a:ln>
         </p:spPr>
@@ -11368,7 +11368,7 @@
             <a:pPr>
               <a:defRPr sz="1400" b="1">
                 <a:solidFill>
-                  <a:srgbClr val="FFC857"/>
+                  <a:srgbClr val="D97706"/>
                 </a:solidFill>
               </a:defRPr>
             </a:pPr>
@@ -11383,7 +11383,7 @@
               </a:spcBef>
               <a:defRPr sz="1200" b="1">
                 <a:solidFill>
-                  <a:srgbClr val="FFFFFF"/>
+                  <a:srgbClr val="0F172A"/>
                 </a:solidFill>
               </a:defRPr>
             </a:pPr>
@@ -11398,7 +11398,7 @@
               </a:spcBef>
               <a:defRPr sz="1150">
                 <a:solidFill>
-                  <a:srgbClr val="E2E8F0"/>
+                  <a:srgbClr val="1E293B"/>
                 </a:solidFill>
               </a:defRPr>
             </a:pPr>
@@ -11441,7 +11441,7 @@
             <a:avLst/>
           </a:prstGeom>
           <a:solidFill>
-            <a:srgbClr val="0B1020"/>
+            <a:srgbClr val="FFFFFF"/>
           </a:solidFill>
           <a:ln>
             <a:noFill/>
@@ -11484,7 +11484,7 @@
             <a:avLst/>
           </a:prstGeom>
           <a:solidFill>
-            <a:srgbClr val="26D9F1"/>
+            <a:srgbClr val="0284C7"/>
           </a:solidFill>
           <a:ln>
             <a:noFill/>
@@ -11537,7 +11537,7 @@
             <a:pPr>
               <a:defRPr sz="2600" b="1">
                 <a:solidFill>
-                  <a:srgbClr val="FFFFFF"/>
+                  <a:srgbClr val="0F172A"/>
                 </a:solidFill>
                 <a:latin typeface="Segoe UI"/>
               </a:defRPr>
@@ -11573,7 +11573,7 @@
             <a:pPr>
               <a:defRPr sz="950">
                 <a:solidFill>
-                  <a:srgbClr val="E2E8F0"/>
+                  <a:srgbClr val="64748B"/>
                 </a:solidFill>
                 <a:latin typeface="Segoe UI"/>
               </a:defRPr>
@@ -11623,11 +11623,11 @@
             <a:avLst/>
           </a:prstGeom>
           <a:solidFill>
-            <a:srgbClr val="151D36"/>
+            <a:srgbClr val="F8FAFC"/>
           </a:solidFill>
           <a:ln w="15240">
             <a:solidFill>
-              <a:srgbClr val="2A3B6A"/>
+              <a:srgbClr val="CBD5E1"/>
             </a:solidFill>
           </a:ln>
         </p:spPr>
@@ -11678,7 +11678,7 @@
             <a:pPr>
               <a:defRPr sz="1500" b="1">
                 <a:solidFill>
-                  <a:srgbClr val="26D9F1"/>
+                  <a:srgbClr val="0284C7"/>
                 </a:solidFill>
               </a:defRPr>
             </a:pPr>
@@ -11693,7 +11693,7 @@
               </a:spcBef>
               <a:defRPr sz="1250">
                 <a:solidFill>
-                  <a:srgbClr val="E2E8F0"/>
+                  <a:srgbClr val="1E293B"/>
                 </a:solidFill>
               </a:defRPr>
             </a:pPr>
@@ -11722,11 +11722,11 @@
             <a:avLst/>
           </a:prstGeom>
           <a:solidFill>
-            <a:srgbClr val="151D36"/>
+            <a:srgbClr val="F8FAFC"/>
           </a:solidFill>
           <a:ln w="15240">
             <a:solidFill>
-              <a:srgbClr val="2A3B6A"/>
+              <a:srgbClr val="CBD5E1"/>
             </a:solidFill>
           </a:ln>
         </p:spPr>
@@ -11777,7 +11777,7 @@
             <a:pPr>
               <a:defRPr sz="1500" b="1">
                 <a:solidFill>
-                  <a:srgbClr val="FFC857"/>
+                  <a:srgbClr val="D97706"/>
                 </a:solidFill>
               </a:defRPr>
             </a:pPr>
@@ -11792,7 +11792,7 @@
               </a:spcBef>
               <a:defRPr sz="1250">
                 <a:solidFill>
-                  <a:srgbClr val="E2E8F0"/>
+                  <a:srgbClr val="1E293B"/>
                 </a:solidFill>
               </a:defRPr>
             </a:pPr>
@@ -11833,11 +11833,11 @@
             <a:avLst/>
           </a:prstGeom>
           <a:solidFill>
-            <a:srgbClr val="151D36"/>
+            <a:srgbClr val="F8FAFC"/>
           </a:solidFill>
           <a:ln w="15240">
             <a:solidFill>
-              <a:srgbClr val="2A3B6A"/>
+              <a:srgbClr val="CBD5E1"/>
             </a:solidFill>
           </a:ln>
         </p:spPr>
@@ -11888,7 +11888,7 @@
             <a:pPr>
               <a:defRPr sz="1500" b="1">
                 <a:solidFill>
-                  <a:srgbClr val="FFFFFF"/>
+                  <a:srgbClr val="0F172A"/>
                 </a:solidFill>
               </a:defRPr>
             </a:pPr>
@@ -11903,7 +11903,7 @@
               </a:spcBef>
               <a:defRPr sz="1250">
                 <a:solidFill>
-                  <a:srgbClr val="E2E8F0"/>
+                  <a:srgbClr val="1E293B"/>
                 </a:solidFill>
               </a:defRPr>
             </a:pPr>
@@ -11954,7 +11954,7 @@
             <a:avLst/>
           </a:prstGeom>
           <a:solidFill>
-            <a:srgbClr val="0B1020"/>
+            <a:srgbClr val="FFFFFF"/>
           </a:solidFill>
           <a:ln>
             <a:noFill/>
@@ -11997,7 +11997,7 @@
             <a:avLst/>
           </a:prstGeom>
           <a:solidFill>
-            <a:srgbClr val="26D9F1"/>
+            <a:srgbClr val="0284C7"/>
           </a:solidFill>
           <a:ln>
             <a:noFill/>
@@ -12050,7 +12050,7 @@
             <a:pPr>
               <a:defRPr sz="2600" b="1">
                 <a:solidFill>
-                  <a:srgbClr val="FFFFFF"/>
+                  <a:srgbClr val="0F172A"/>
                 </a:solidFill>
                 <a:latin typeface="Segoe UI"/>
               </a:defRPr>
@@ -12086,7 +12086,7 @@
             <a:pPr>
               <a:defRPr sz="950">
                 <a:solidFill>
-                  <a:srgbClr val="E2E8F0"/>
+                  <a:srgbClr val="64748B"/>
                 </a:solidFill>
                 <a:latin typeface="Segoe UI"/>
               </a:defRPr>
@@ -12136,11 +12136,11 @@
             <a:avLst/>
           </a:prstGeom>
           <a:solidFill>
-            <a:srgbClr val="151D36"/>
+            <a:srgbClr val="F8FAFC"/>
           </a:solidFill>
           <a:ln w="15240">
             <a:solidFill>
-              <a:srgbClr val="2A3B6A"/>
+              <a:srgbClr val="CBD5E1"/>
             </a:solidFill>
           </a:ln>
         </p:spPr>
@@ -12191,7 +12191,7 @@
             <a:pPr>
               <a:defRPr sz="1500" b="1">
                 <a:solidFill>
-                  <a:srgbClr val="26D9F1"/>
+                  <a:srgbClr val="0284C7"/>
                 </a:solidFill>
               </a:defRPr>
             </a:pPr>
@@ -12206,7 +12206,7 @@
               </a:spcBef>
               <a:defRPr sz="1200">
                 <a:solidFill>
-                  <a:srgbClr val="E2E8F0"/>
+                  <a:srgbClr val="1E293B"/>
                 </a:solidFill>
               </a:defRPr>
             </a:pPr>
@@ -12243,11 +12243,11 @@
             <a:avLst/>
           </a:prstGeom>
           <a:solidFill>
-            <a:srgbClr val="151D36"/>
+            <a:srgbClr val="F8FAFC"/>
           </a:solidFill>
           <a:ln w="15240">
             <a:solidFill>
-              <a:srgbClr val="2A3B6A"/>
+              <a:srgbClr val="CBD5E1"/>
             </a:solidFill>
           </a:ln>
         </p:spPr>
@@ -12298,7 +12298,7 @@
             <a:pPr>
               <a:defRPr sz="1500" b="1">
                 <a:solidFill>
-                  <a:srgbClr val="FFC857"/>
+                  <a:srgbClr val="D97706"/>
                 </a:solidFill>
               </a:defRPr>
             </a:pPr>
@@ -12313,7 +12313,7 @@
               </a:spcBef>
               <a:defRPr sz="1200">
                 <a:solidFill>
-                  <a:srgbClr val="E2E8F0"/>
+                  <a:srgbClr val="1E293B"/>
                 </a:solidFill>
               </a:defRPr>
             </a:pPr>
@@ -12350,11 +12350,11 @@
             <a:avLst/>
           </a:prstGeom>
           <a:solidFill>
-            <a:srgbClr val="151D36"/>
+            <a:srgbClr val="F8FAFC"/>
           </a:solidFill>
           <a:ln w="15240">
             <a:solidFill>
-              <a:srgbClr val="2A3B6A"/>
+              <a:srgbClr val="CBD5E1"/>
             </a:solidFill>
           </a:ln>
         </p:spPr>
@@ -12405,7 +12405,7 @@
             <a:pPr>
               <a:defRPr sz="1500" b="1">
                 <a:solidFill>
-                  <a:srgbClr val="FF6B6B"/>
+                  <a:srgbClr val="DC2626"/>
                 </a:solidFill>
               </a:defRPr>
             </a:pPr>
@@ -12420,7 +12420,7 @@
               </a:spcBef>
               <a:defRPr sz="1200">
                 <a:solidFill>
-                  <a:srgbClr val="E2E8F0"/>
+                  <a:srgbClr val="1E293B"/>
                 </a:solidFill>
               </a:defRPr>
             </a:pPr>
@@ -12475,7 +12475,7 @@
             <a:avLst/>
           </a:prstGeom>
           <a:solidFill>
-            <a:srgbClr val="0B1020"/>
+            <a:srgbClr val="FFFFFF"/>
           </a:solidFill>
           <a:ln>
             <a:noFill/>
@@ -12518,7 +12518,7 @@
             <a:avLst/>
           </a:prstGeom>
           <a:solidFill>
-            <a:srgbClr val="26D9F1"/>
+            <a:srgbClr val="0284C7"/>
           </a:solidFill>
           <a:ln>
             <a:noFill/>
@@ -12571,7 +12571,7 @@
             <a:pPr>
               <a:defRPr sz="2600" b="1">
                 <a:solidFill>
-                  <a:srgbClr val="FFFFFF"/>
+                  <a:srgbClr val="0F172A"/>
                 </a:solidFill>
                 <a:latin typeface="Segoe UI"/>
               </a:defRPr>
@@ -12607,7 +12607,7 @@
             <a:pPr>
               <a:defRPr sz="950">
                 <a:solidFill>
-                  <a:srgbClr val="E2E8F0"/>
+                  <a:srgbClr val="64748B"/>
                 </a:solidFill>
                 <a:latin typeface="Segoe UI"/>
               </a:defRPr>
@@ -12657,11 +12657,11 @@
             <a:avLst/>
           </a:prstGeom>
           <a:solidFill>
-            <a:srgbClr val="151D36"/>
+            <a:srgbClr val="F8FAFC"/>
           </a:solidFill>
           <a:ln w="15240">
             <a:solidFill>
-              <a:srgbClr val="2A3B6A"/>
+              <a:srgbClr val="CBD5E1"/>
             </a:solidFill>
           </a:ln>
         </p:spPr>
@@ -12712,7 +12712,7 @@
             <a:pPr>
               <a:defRPr sz="1500" b="1">
                 <a:solidFill>
-                  <a:srgbClr val="26D9F1"/>
+                  <a:srgbClr val="0284C7"/>
                 </a:solidFill>
               </a:defRPr>
             </a:pPr>
@@ -12727,7 +12727,7 @@
               </a:spcBef>
               <a:defRPr sz="1200">
                 <a:solidFill>
-                  <a:srgbClr val="E2E8F0"/>
+                  <a:srgbClr val="1E293B"/>
                 </a:solidFill>
               </a:defRPr>
             </a:pPr>
@@ -12756,11 +12756,11 @@
             <a:avLst/>
           </a:prstGeom>
           <a:solidFill>
-            <a:srgbClr val="151D36"/>
+            <a:srgbClr val="F8FAFC"/>
           </a:solidFill>
           <a:ln w="15240">
             <a:solidFill>
-              <a:srgbClr val="2A3B6A"/>
+              <a:srgbClr val="CBD5E1"/>
             </a:solidFill>
           </a:ln>
         </p:spPr>
@@ -12811,7 +12811,7 @@
             <a:pPr>
               <a:defRPr sz="1500" b="1">
                 <a:solidFill>
-                  <a:srgbClr val="FFC857"/>
+                  <a:srgbClr val="D97706"/>
                 </a:solidFill>
               </a:defRPr>
             </a:pPr>
@@ -12826,7 +12826,7 @@
               </a:spcBef>
               <a:defRPr sz="1200">
                 <a:solidFill>
-                  <a:srgbClr val="E2E8F0"/>
+                  <a:srgbClr val="1E293B"/>
                 </a:solidFill>
               </a:defRPr>
             </a:pPr>
@@ -12867,11 +12867,11 @@
             <a:avLst/>
           </a:prstGeom>
           <a:solidFill>
-            <a:srgbClr val="151D36"/>
+            <a:srgbClr val="F8FAFC"/>
           </a:solidFill>
           <a:ln w="15240">
             <a:solidFill>
-              <a:srgbClr val="2A3B6A"/>
+              <a:srgbClr val="CBD5E1"/>
             </a:solidFill>
           </a:ln>
         </p:spPr>
@@ -12922,7 +12922,7 @@
             <a:pPr>
               <a:defRPr sz="1500" b="1">
                 <a:solidFill>
-                  <a:srgbClr val="FFFFFF"/>
+                  <a:srgbClr val="0F172A"/>
                 </a:solidFill>
               </a:defRPr>
             </a:pPr>
@@ -12937,7 +12937,7 @@
               </a:spcBef>
               <a:defRPr sz="1200">
                 <a:solidFill>
-                  <a:srgbClr val="E2E8F0"/>
+                  <a:srgbClr val="1E293B"/>
                 </a:solidFill>
               </a:defRPr>
             </a:pPr>
@@ -12992,7 +12992,7 @@
             <a:avLst/>
           </a:prstGeom>
           <a:solidFill>
-            <a:srgbClr val="0B1020"/>
+            <a:srgbClr val="FFFFFF"/>
           </a:solidFill>
           <a:ln>
             <a:noFill/>
@@ -13035,7 +13035,7 @@
             <a:avLst/>
           </a:prstGeom>
           <a:solidFill>
-            <a:srgbClr val="26D9F1"/>
+            <a:srgbClr val="0284C7"/>
           </a:solidFill>
           <a:ln>
             <a:noFill/>
@@ -13088,7 +13088,7 @@
             <a:pPr>
               <a:defRPr sz="2600" b="1">
                 <a:solidFill>
-                  <a:srgbClr val="FFFFFF"/>
+                  <a:srgbClr val="0F172A"/>
                 </a:solidFill>
                 <a:latin typeface="Segoe UI"/>
               </a:defRPr>
@@ -13124,7 +13124,7 @@
             <a:pPr>
               <a:defRPr sz="950">
                 <a:solidFill>
-                  <a:srgbClr val="E2E8F0"/>
+                  <a:srgbClr val="64748B"/>
                 </a:solidFill>
                 <a:latin typeface="Segoe UI"/>
               </a:defRPr>
@@ -13174,11 +13174,11 @@
             <a:avLst/>
           </a:prstGeom>
           <a:solidFill>
-            <a:srgbClr val="151D36"/>
+            <a:srgbClr val="F8FAFC"/>
           </a:solidFill>
           <a:ln w="15240">
             <a:solidFill>
-              <a:srgbClr val="2A3B6A"/>
+              <a:srgbClr val="CBD5E1"/>
             </a:solidFill>
           </a:ln>
         </p:spPr>
@@ -13229,7 +13229,7 @@
             <a:pPr>
               <a:defRPr sz="1500" b="1">
                 <a:solidFill>
-                  <a:srgbClr val="FFC857"/>
+                  <a:srgbClr val="D97706"/>
                 </a:solidFill>
               </a:defRPr>
             </a:pPr>
@@ -13246,7 +13246,7 @@
             <a:r>
               <a:rPr b="1" sz="1200">
                 <a:solidFill>
-                  <a:srgbClr val="FFFFFF"/>
+                  <a:srgbClr val="0F172A"/>
                 </a:solidFill>
               </a:rPr>
               <a:t>Training Files Processed: </a:t>
@@ -13254,7 +13254,7 @@
             <a:r>
               <a:rPr sz="1250" b="1">
                 <a:solidFill>
-                  <a:srgbClr val="26D9F1"/>
+                  <a:srgbClr val="0284C7"/>
                 </a:solidFill>
               </a:rPr>
               <a:t>13 → 962 (74× Increase)</a:t>
@@ -13269,7 +13269,7 @@
             <a:r>
               <a:rPr b="1" sz="1200">
                 <a:solidFill>
-                  <a:srgbClr val="FFFFFF"/>
+                  <a:srgbClr val="0F172A"/>
                 </a:solidFill>
               </a:rPr>
               <a:t>Extracted Note Events: </a:t>
@@ -13277,7 +13277,7 @@
             <a:r>
               <a:rPr sz="1250" b="1">
                 <a:solidFill>
-                  <a:srgbClr val="26D9F1"/>
+                  <a:srgbClr val="0284C7"/>
                 </a:solidFill>
               </a:rPr>
               <a:t>64,261 → 5,659,329 (88× Increase)</a:t>
@@ -13292,7 +13292,7 @@
             <a:r>
               <a:rPr b="1" sz="1200">
                 <a:solidFill>
-                  <a:srgbClr val="FFFFFF"/>
+                  <a:srgbClr val="0F172A"/>
                 </a:solidFill>
               </a:rPr>
               <a:t>Training Sequences: </a:t>
@@ -13300,7 +13300,7 @@
             <a:r>
               <a:rPr sz="1250" b="1">
                 <a:solidFill>
-                  <a:srgbClr val="26D9F1"/>
+                  <a:srgbClr val="0284C7"/>
                 </a:solidFill>
               </a:rPr>
               <a:t>15,000 → 100,000 (6.7× Increase)</a:t>
@@ -13315,7 +13315,7 @@
             <a:r>
               <a:rPr b="1" sz="1200">
                 <a:solidFill>
-                  <a:srgbClr val="FFFFFF"/>
+                  <a:srgbClr val="0F172A"/>
                 </a:solidFill>
               </a:rPr>
               <a:t>Validation Performances: </a:t>
@@ -13323,7 +13323,7 @@
             <a:r>
               <a:rPr sz="1250" b="1">
                 <a:solidFill>
-                  <a:srgbClr val="26D9F1"/>
+                  <a:srgbClr val="0284C7"/>
                 </a:solidFill>
               </a:rPr>
               <a:t>1 → 137 (137× Increase)</a:t>
@@ -13338,7 +13338,7 @@
             <a:r>
               <a:rPr b="1" sz="1200">
                 <a:solidFill>
-                  <a:srgbClr val="FFFFFF"/>
+                  <a:srgbClr val="0F172A"/>
                 </a:solidFill>
               </a:rPr>
               <a:t>Validation Sequences: </a:t>
@@ -13346,7 +13346,7 @@
             <a:r>
               <a:rPr sz="1250" b="1">
                 <a:solidFill>
-                  <a:srgbClr val="26D9F1"/>
+                  <a:srgbClr val="0284C7"/>
                 </a:solidFill>
               </a:rPr>
               <a:t>3,924 → 10,000 (2.5× Increase)</a:t>
@@ -13361,7 +13361,7 @@
             <a:r>
               <a:rPr b="1" sz="1200">
                 <a:solidFill>
-                  <a:srgbClr val="FFFFFF"/>
+                  <a:srgbClr val="0F172A"/>
                 </a:solidFill>
               </a:rPr>
               <a:t>RAM Representation: </a:t>
@@ -13369,7 +13369,7 @@
             <a:r>
               <a:rPr sz="1250" b="1">
                 <a:solidFill>
-                  <a:srgbClr val="26D9F1"/>
+                  <a:srgbClr val="0284C7"/>
                 </a:solidFill>
               </a:rPr>
               <a:t>int64 (77 MB) → uint8 (9.6 MB)</a:t>
@@ -13384,7 +13384,7 @@
             <a:r>
               <a:rPr b="1" sz="1200">
                 <a:solidFill>
-                  <a:srgbClr val="FFFFFF"/>
+                  <a:srgbClr val="0F172A"/>
                 </a:solidFill>
               </a:rPr>
               <a:t>Cached Load Time: </a:t>
@@ -13392,7 +13392,7 @@
             <a:r>
               <a:rPr sz="1250" b="1">
                 <a:solidFill>
-                  <a:srgbClr val="26D9F1"/>
+                  <a:srgbClr val="0284C7"/>
                 </a:solidFill>
               </a:rPr>
               <a:t>10s → 1.88s (Train) / 0.26s (Val)</a:t>
@@ -13415,11 +13415,11 @@
             <a:avLst/>
           </a:prstGeom>
           <a:solidFill>
-            <a:srgbClr val="151D36"/>
+            <a:srgbClr val="F8FAFC"/>
           </a:solidFill>
           <a:ln w="15240">
             <a:solidFill>
-              <a:srgbClr val="2A3B6A"/>
+              <a:srgbClr val="CBD5E1"/>
             </a:solidFill>
           </a:ln>
         </p:spPr>
@@ -13470,7 +13470,7 @@
             <a:pPr>
               <a:defRPr sz="1500" b="1">
                 <a:solidFill>
-                  <a:srgbClr val="26D9F1"/>
+                  <a:srgbClr val="0284C7"/>
                 </a:solidFill>
               </a:defRPr>
             </a:pPr>
@@ -13485,7 +13485,7 @@
               </a:spcBef>
               <a:defRPr sz="1200">
                 <a:solidFill>
-                  <a:srgbClr val="E2E8F0"/>
+                  <a:srgbClr val="1E293B"/>
                 </a:solidFill>
               </a:defRPr>
             </a:pPr>
@@ -13500,7 +13500,7 @@
               </a:spcBef>
               <a:defRPr sz="1200">
                 <a:solidFill>
-                  <a:srgbClr val="E2E8F0"/>
+                  <a:srgbClr val="1E293B"/>
                 </a:solidFill>
               </a:defRPr>
             </a:pPr>
@@ -13515,7 +13515,7 @@
               </a:spcBef>
               <a:defRPr sz="1200">
                 <a:solidFill>
-                  <a:srgbClr val="E2E8F0"/>
+                  <a:srgbClr val="1E293B"/>
                 </a:solidFill>
               </a:defRPr>
             </a:pPr>
@@ -13558,7 +13558,7 @@
             <a:avLst/>
           </a:prstGeom>
           <a:solidFill>
-            <a:srgbClr val="0B1020"/>
+            <a:srgbClr val="FFFFFF"/>
           </a:solidFill>
           <a:ln>
             <a:noFill/>
@@ -13601,7 +13601,7 @@
             <a:avLst/>
           </a:prstGeom>
           <a:solidFill>
-            <a:srgbClr val="26D9F1"/>
+            <a:srgbClr val="0284C7"/>
           </a:solidFill>
           <a:ln>
             <a:noFill/>
@@ -13654,7 +13654,7 @@
             <a:pPr>
               <a:defRPr sz="2600" b="1">
                 <a:solidFill>
-                  <a:srgbClr val="FFFFFF"/>
+                  <a:srgbClr val="0F172A"/>
                 </a:solidFill>
                 <a:latin typeface="Segoe UI"/>
               </a:defRPr>
@@ -13690,7 +13690,7 @@
             <a:pPr>
               <a:defRPr sz="950">
                 <a:solidFill>
-                  <a:srgbClr val="E2E8F0"/>
+                  <a:srgbClr val="64748B"/>
                 </a:solidFill>
                 <a:latin typeface="Segoe UI"/>
               </a:defRPr>
@@ -13716,11 +13716,11 @@
             <a:avLst/>
           </a:prstGeom>
           <a:solidFill>
-            <a:srgbClr val="151D36"/>
+            <a:srgbClr val="F8FAFC"/>
           </a:solidFill>
           <a:ln w="15240">
             <a:solidFill>
-              <a:srgbClr val="2A3B6A"/>
+              <a:srgbClr val="CBD5E1"/>
             </a:solidFill>
           </a:ln>
         </p:spPr>
@@ -13771,7 +13771,7 @@
             <a:pPr>
               <a:defRPr sz="1500" b="1">
                 <a:solidFill>
-                  <a:srgbClr val="26D9F1"/>
+                  <a:srgbClr val="0284C7"/>
                 </a:solidFill>
               </a:defRPr>
             </a:pPr>
@@ -13786,7 +13786,7 @@
               </a:spcBef>
               <a:defRPr sz="1250" b="1">
                 <a:solidFill>
-                  <a:srgbClr val="FFFFFF"/>
+                  <a:srgbClr val="0F172A"/>
                 </a:solidFill>
               </a:defRPr>
             </a:pPr>
@@ -13801,7 +13801,7 @@
               </a:spcBef>
               <a:defRPr sz="1200">
                 <a:solidFill>
-                  <a:srgbClr val="E2E8F0"/>
+                  <a:srgbClr val="1E293B"/>
                 </a:solidFill>
               </a:defRPr>
             </a:pPr>
@@ -13826,11 +13826,11 @@
             <a:avLst/>
           </a:prstGeom>
           <a:solidFill>
-            <a:srgbClr val="151D36"/>
+            <a:srgbClr val="F8FAFC"/>
           </a:solidFill>
           <a:ln w="15240">
             <a:solidFill>
-              <a:srgbClr val="2A3B6A"/>
+              <a:srgbClr val="CBD5E1"/>
             </a:solidFill>
           </a:ln>
         </p:spPr>
@@ -13881,7 +13881,7 @@
             <a:pPr>
               <a:defRPr sz="1500" b="1">
                 <a:solidFill>
-                  <a:srgbClr val="FFFFFF"/>
+                  <a:srgbClr val="0F172A"/>
                 </a:solidFill>
               </a:defRPr>
             </a:pPr>
@@ -13896,7 +13896,7 @@
               </a:spcBef>
               <a:defRPr sz="1250" b="1">
                 <a:solidFill>
-                  <a:srgbClr val="FFFFFF"/>
+                  <a:srgbClr val="0F172A"/>
                 </a:solidFill>
               </a:defRPr>
             </a:pPr>
@@ -13911,7 +13911,7 @@
               </a:spcBef>
               <a:defRPr sz="1200">
                 <a:solidFill>
-                  <a:srgbClr val="E2E8F0"/>
+                  <a:srgbClr val="1E293B"/>
                 </a:solidFill>
               </a:defRPr>
             </a:pPr>
@@ -13936,11 +13936,11 @@
             <a:avLst/>
           </a:prstGeom>
           <a:solidFill>
-            <a:srgbClr val="151D36"/>
+            <a:srgbClr val="F8FAFC"/>
           </a:solidFill>
           <a:ln w="15240">
             <a:solidFill>
-              <a:srgbClr val="2A3B6A"/>
+              <a:srgbClr val="CBD5E1"/>
             </a:solidFill>
           </a:ln>
         </p:spPr>
@@ -13991,7 +13991,7 @@
             <a:pPr>
               <a:defRPr sz="1500" b="1">
                 <a:solidFill>
-                  <a:srgbClr val="FFC857"/>
+                  <a:srgbClr val="D97706"/>
                 </a:solidFill>
               </a:defRPr>
             </a:pPr>
@@ -14006,7 +14006,7 @@
               </a:spcBef>
               <a:defRPr sz="1250" b="1">
                 <a:solidFill>
-                  <a:srgbClr val="FFFFFF"/>
+                  <a:srgbClr val="0F172A"/>
                 </a:solidFill>
               </a:defRPr>
             </a:pPr>
@@ -14021,7 +14021,7 @@
               </a:spcBef>
               <a:defRPr sz="1200">
                 <a:solidFill>
-                  <a:srgbClr val="E2E8F0"/>
+                  <a:srgbClr val="1E293B"/>
                 </a:solidFill>
               </a:defRPr>
             </a:pPr>
@@ -14046,11 +14046,11 @@
             <a:avLst/>
           </a:prstGeom>
           <a:solidFill>
-            <a:srgbClr val="151D36"/>
+            <a:srgbClr val="F8FAFC"/>
           </a:solidFill>
           <a:ln w="15240">
             <a:solidFill>
-              <a:srgbClr val="2A3B6A"/>
+              <a:srgbClr val="CBD5E1"/>
             </a:solidFill>
           </a:ln>
         </p:spPr>
@@ -14101,7 +14101,7 @@
             <a:pPr>
               <a:defRPr sz="1500" b="1">
                 <a:solidFill>
-                  <a:srgbClr val="22C55E"/>
+                  <a:srgbClr val="16A34A"/>
                 </a:solidFill>
               </a:defRPr>
             </a:pPr>
@@ -14116,7 +14116,7 @@
               </a:spcBef>
               <a:defRPr sz="1250" b="1">
                 <a:solidFill>
-                  <a:srgbClr val="FFFFFF"/>
+                  <a:srgbClr val="0F172A"/>
                 </a:solidFill>
               </a:defRPr>
             </a:pPr>
@@ -14131,7 +14131,7 @@
               </a:spcBef>
               <a:defRPr sz="1200">
                 <a:solidFill>
-                  <a:srgbClr val="E2E8F0"/>
+                  <a:srgbClr val="1E293B"/>
                 </a:solidFill>
               </a:defRPr>
             </a:pPr>
@@ -14156,11 +14156,11 @@
             <a:avLst/>
           </a:prstGeom>
           <a:solidFill>
-            <a:srgbClr val="151D36"/>
+            <a:srgbClr val="F8FAFC"/>
           </a:solidFill>
           <a:ln w="15240">
             <a:solidFill>
-              <a:srgbClr val="2A3B6A"/>
+              <a:srgbClr val="CBD5E1"/>
             </a:solidFill>
           </a:ln>
         </p:spPr>
@@ -14211,7 +14211,7 @@
             <a:pPr>
               <a:defRPr sz="1500" b="1">
                 <a:solidFill>
-                  <a:srgbClr val="26D9F1"/>
+                  <a:srgbClr val="0284C7"/>
                 </a:solidFill>
               </a:defRPr>
             </a:pPr>
@@ -14226,7 +14226,7 @@
               </a:spcBef>
               <a:defRPr sz="1250">
                 <a:solidFill>
-                  <a:srgbClr val="E2E8F0"/>
+                  <a:srgbClr val="1E293B"/>
                 </a:solidFill>
               </a:defRPr>
             </a:pPr>
@@ -14286,7 +14286,7 @@
             <a:avLst/>
           </a:prstGeom>
           <a:solidFill>
-            <a:srgbClr val="0B1020"/>
+            <a:srgbClr val="FFFFFF"/>
           </a:solidFill>
           <a:ln>
             <a:noFill/>
@@ -14329,7 +14329,7 @@
             <a:avLst/>
           </a:prstGeom>
           <a:solidFill>
-            <a:srgbClr val="26D9F1"/>
+            <a:srgbClr val="0284C7"/>
           </a:solidFill>
           <a:ln>
             <a:noFill/>
@@ -14382,7 +14382,7 @@
             <a:pPr>
               <a:defRPr sz="2600" b="1">
                 <a:solidFill>
-                  <a:srgbClr val="FFFFFF"/>
+                  <a:srgbClr val="0F172A"/>
                 </a:solidFill>
                 <a:latin typeface="Segoe UI"/>
               </a:defRPr>
@@ -14418,7 +14418,7 @@
             <a:pPr>
               <a:defRPr sz="950">
                 <a:solidFill>
-                  <a:srgbClr val="E2E8F0"/>
+                  <a:srgbClr val="64748B"/>
                 </a:solidFill>
                 <a:latin typeface="Segoe UI"/>
               </a:defRPr>
@@ -14444,11 +14444,11 @@
             <a:avLst/>
           </a:prstGeom>
           <a:solidFill>
-            <a:srgbClr val="151D36"/>
+            <a:srgbClr val="F8FAFC"/>
           </a:solidFill>
           <a:ln w="15240">
             <a:solidFill>
-              <a:srgbClr val="2A3B6A"/>
+              <a:srgbClr val="CBD5E1"/>
             </a:solidFill>
           </a:ln>
         </p:spPr>
@@ -14499,7 +14499,7 @@
             <a:pPr>
               <a:defRPr sz="1500" b="1">
                 <a:solidFill>
-                  <a:srgbClr val="26D9F1"/>
+                  <a:srgbClr val="0284C7"/>
                 </a:solidFill>
               </a:defRPr>
             </a:pPr>
@@ -14514,7 +14514,7 @@
               </a:spcBef>
               <a:defRPr sz="1300">
                 <a:solidFill>
-                  <a:srgbClr val="E2E8F0"/>
+                  <a:srgbClr val="1E293B"/>
                 </a:solidFill>
               </a:defRPr>
             </a:pPr>
@@ -14545,7 +14545,7 @@
               </a:spcBef>
               <a:defRPr sz="1200" b="1">
                 <a:solidFill>
-                  <a:srgbClr val="FFC857"/>
+                  <a:srgbClr val="D97706"/>
                 </a:solidFill>
                 <a:latin typeface="Consolas"/>
               </a:defRPr>
@@ -14575,11 +14575,11 @@
             <a:avLst/>
           </a:prstGeom>
           <a:solidFill>
-            <a:srgbClr val="151D36"/>
+            <a:srgbClr val="F8FAFC"/>
           </a:solidFill>
           <a:ln w="15240">
             <a:solidFill>
-              <a:srgbClr val="2A3B6A"/>
+              <a:srgbClr val="CBD5E1"/>
             </a:solidFill>
           </a:ln>
         </p:spPr>
@@ -14630,7 +14630,7 @@
             <a:pPr>
               <a:defRPr sz="1500" b="1">
                 <a:solidFill>
-                  <a:srgbClr val="FFC857"/>
+                  <a:srgbClr val="D97706"/>
                 </a:solidFill>
               </a:defRPr>
             </a:pPr>
@@ -14647,7 +14647,7 @@
             <a:r>
               <a:rPr b="1" sz="1250">
                 <a:solidFill>
-                  <a:srgbClr val="FFFFFF"/>
+                  <a:srgbClr val="0F172A"/>
                 </a:solidFill>
               </a:rPr>
               <a:t>• Pitch Target (y_p): </a:t>
@@ -14655,7 +14655,7 @@
             <a:r>
               <a:rPr sz="1200">
                 <a:solidFill>
-                  <a:srgbClr val="E2E8F0"/>
+                  <a:srgbClr val="1E293B"/>
                 </a:solidFill>
               </a:rPr>
               <a:t> Discrete classification over 128 MIDI pitch classes [0, 127].</a:t>
@@ -14670,7 +14670,7 @@
             <a:r>
               <a:rPr b="1" sz="1250">
                 <a:solidFill>
-                  <a:srgbClr val="FFFFFF"/>
+                  <a:srgbClr val="0F172A"/>
                 </a:solidFill>
               </a:rPr>
               <a:t>• Duration Target (y_d): </a:t>
@@ -14678,7 +14678,7 @@
             <a:r>
               <a:rPr sz="1200">
                 <a:solidFill>
-                  <a:srgbClr val="E2E8F0"/>
+                  <a:srgbClr val="1E293B"/>
                 </a:solidFill>
               </a:rPr>
               <a:t> Discrete classification over 32 quantized duration bins [0, 31].</a:t>
@@ -14693,7 +14693,7 @@
             <a:r>
               <a:rPr b="1" sz="1250">
                 <a:solidFill>
-                  <a:srgbClr val="FFFFFF"/>
+                  <a:srgbClr val="0F172A"/>
                 </a:solidFill>
               </a:rPr>
               <a:t>• Step Interval Target (y_s): </a:t>
@@ -14701,7 +14701,7 @@
             <a:r>
               <a:rPr sz="1200">
                 <a:solidFill>
-                  <a:srgbClr val="E2E8F0"/>
+                  <a:srgbClr val="1E293B"/>
                 </a:solidFill>
               </a:rPr>
               <a:t> Discrete classification over 32 quantized step bins [0, 31].</a:t>
@@ -14716,7 +14716,7 @@
             <a:r>
               <a:rPr b="1" sz="1250">
                 <a:solidFill>
-                  <a:srgbClr val="FFFFFF"/>
+                  <a:srgbClr val="0F172A"/>
                 </a:solidFill>
               </a:rPr>
               <a:t>• Synchronous Backprop: </a:t>
@@ -14724,7 +14724,7 @@
             <a:r>
               <a:rPr sz="1200">
                 <a:solidFill>
-                  <a:srgbClr val="E2E8F0"/>
+                  <a:srgbClr val="1E293B"/>
                 </a:solidFill>
               </a:rPr>
               <a:t> All three targets are predicted simultaneously from the final LSTM hidden state h_32.</a:t>
@@ -14747,11 +14747,11 @@
             <a:avLst/>
           </a:prstGeom>
           <a:solidFill>
-            <a:srgbClr val="151D36"/>
+            <a:srgbClr val="F8FAFC"/>
           </a:solidFill>
           <a:ln w="15240">
             <a:solidFill>
-              <a:srgbClr val="2A3B6A"/>
+              <a:srgbClr val="CBD5E1"/>
             </a:solidFill>
           </a:ln>
         </p:spPr>
@@ -14802,7 +14802,7 @@
             <a:pPr>
               <a:defRPr sz="1500" b="1">
                 <a:solidFill>
-                  <a:srgbClr val="FFFFFF"/>
+                  <a:srgbClr val="0F172A"/>
                 </a:solidFill>
               </a:defRPr>
             </a:pPr>
@@ -14819,7 +14819,7 @@
             <a:r>
               <a:rPr b="1" sz="1250">
                 <a:solidFill>
-                  <a:srgbClr val="FFFFFF"/>
+                  <a:srgbClr val="0F172A"/>
                 </a:solidFill>
               </a:rPr>
               <a:t>✓ Strict Chronological Order: </a:t>
@@ -14827,7 +14827,7 @@
             <a:r>
               <a:rPr sz="1200">
                 <a:solidFill>
-                  <a:srgbClr val="E2E8F0"/>
+                  <a:srgbClr val="1E293B"/>
                 </a:solidFill>
               </a:rPr>
               <a:t> Notes are sorted by start time prior to sliding; future events never precede past events.</a:t>
@@ -14842,7 +14842,7 @@
             <a:r>
               <a:rPr b="1" sz="1250">
                 <a:solidFill>
-                  <a:srgbClr val="FFFFFF"/>
+                  <a:srgbClr val="0F172A"/>
                 </a:solidFill>
               </a:rPr>
               <a:t>✓ No Lookahead Leakage: </a:t>
@@ -14850,7 +14850,7 @@
             <a:r>
               <a:rPr sz="1200">
                 <a:solidFill>
-                  <a:srgbClr val="E2E8F0"/>
+                  <a:srgbClr val="1E293B"/>
                 </a:solidFill>
               </a:rPr>
               <a:t> Window i only contains notes 1..32; target is note 33. The recurrent state only sees past history.</a:t>
@@ -14865,7 +14865,7 @@
             <a:r>
               <a:rPr b="1" sz="1250">
                 <a:solidFill>
-                  <a:srgbClr val="FFFFFF"/>
+                  <a:srgbClr val="0F172A"/>
                 </a:solidFill>
               </a:rPr>
               <a:t>✓ Piece Boundary Isolation: </a:t>
@@ -14873,7 +14873,7 @@
             <a:r>
               <a:rPr sz="1200">
                 <a:solidFill>
-                  <a:srgbClr val="E2E8F0"/>
+                  <a:srgbClr val="1E293B"/>
                 </a:solidFill>
               </a:rPr>
               <a:t> Sequences are strictly constructed within individual performances; windows never span across different MIDI files.</a:t>
@@ -14888,7 +14888,7 @@
             <a:r>
               <a:rPr b="1" sz="1250">
                 <a:solidFill>
-                  <a:srgbClr val="FFFFFF"/>
+                  <a:srgbClr val="0F172A"/>
                 </a:solidFill>
               </a:rPr>
               <a:t>✓ Unit Tests Verified: </a:t>
@@ -14896,7 +14896,7 @@
             <a:r>
               <a:rPr sz="1200">
                 <a:solidFill>
-                  <a:srgbClr val="E2E8F0"/>
+                  <a:srgbClr val="1E293B"/>
                 </a:solidFill>
               </a:rPr>
               <a:t> test_sequence_generation_and_dataset and test_proportional_event_sequence_generation both pass.</a:t>

</xml_diff>